<commit_message>
Revise local AI benefits slide
</commit_message>
<xml_diff>
--- a/outputs/presentations/Will AI Be Completely Free - Final.pptx
+++ b/outputs/presentations/Will AI Be Completely Free - Final.pptx
@@ -2,25 +2,25 @@
 <file path=ppt/presentation.xml><?xml version="1.0" encoding="utf-8"?>
 <p:presentation xmlns:p="http://schemas.openxmlformats.org/presentationml/2006/main">
   <p:sldMasterIdLst>
-    <p:sldMasterId xmlns:r="http://schemas.openxmlformats.org/officeDocument/2006/relationships" id="2147483648" r:id="R4cc773e342484079"/>
+    <p:sldMasterId xmlns:r="http://schemas.openxmlformats.org/officeDocument/2006/relationships" id="2147483648" r:id="Rf06c90b66dc14c4f"/>
   </p:sldMasterIdLst>
   <p:notesMasterIdLst>
-    <p:notesMasterId xmlns:r="http://schemas.openxmlformats.org/officeDocument/2006/relationships" r:id="R7c837c055efc456d"/>
+    <p:notesMasterId xmlns:r="http://schemas.openxmlformats.org/officeDocument/2006/relationships" r:id="Ra9a1997eb1974c78"/>
   </p:notesMasterIdLst>
   <p:sldIdLst>
-    <p:sldId xmlns:r="http://schemas.openxmlformats.org/officeDocument/2006/relationships" id="256" r:id="R370bc72a794f4864"/>
-    <p:sldId xmlns:r="http://schemas.openxmlformats.org/officeDocument/2006/relationships" id="257" r:id="R7dccfa16033444c7"/>
-    <p:sldId xmlns:r="http://schemas.openxmlformats.org/officeDocument/2006/relationships" id="258" r:id="R0c6b145894c147b8"/>
-    <p:sldId xmlns:r="http://schemas.openxmlformats.org/officeDocument/2006/relationships" id="259" r:id="Rbc5c5b5dcc7d42e7"/>
-    <p:sldId xmlns:r="http://schemas.openxmlformats.org/officeDocument/2006/relationships" id="260" r:id="Rb4cd22d086324072"/>
-    <p:sldId xmlns:r="http://schemas.openxmlformats.org/officeDocument/2006/relationships" id="261" r:id="Rac14e7ab808f49e8"/>
-    <p:sldId xmlns:r="http://schemas.openxmlformats.org/officeDocument/2006/relationships" id="262" r:id="Rf17d9ff92e904e0b"/>
-    <p:sldId xmlns:r="http://schemas.openxmlformats.org/officeDocument/2006/relationships" id="263" r:id="Rd026dd9598a44200"/>
-    <p:sldId xmlns:r="http://schemas.openxmlformats.org/officeDocument/2006/relationships" id="264" r:id="Rdf629d1d6cc04593"/>
-    <p:sldId xmlns:r="http://schemas.openxmlformats.org/officeDocument/2006/relationships" id="265" r:id="R45901b0a9d464789"/>
-    <p:sldId xmlns:r="http://schemas.openxmlformats.org/officeDocument/2006/relationships" id="266" r:id="R107efa59a4fc43c3"/>
-    <p:sldId xmlns:r="http://schemas.openxmlformats.org/officeDocument/2006/relationships" id="267" r:id="R4ceed4baa4c04907"/>
-    <p:sldId xmlns:r="http://schemas.openxmlformats.org/officeDocument/2006/relationships" id="268" r:id="Ra7f71f4b2da54915"/>
+    <p:sldId xmlns:r="http://schemas.openxmlformats.org/officeDocument/2006/relationships" id="256" r:id="R08c1cbf6d6634f1f"/>
+    <p:sldId xmlns:r="http://schemas.openxmlformats.org/officeDocument/2006/relationships" id="257" r:id="R3f845a17d54843cc"/>
+    <p:sldId xmlns:r="http://schemas.openxmlformats.org/officeDocument/2006/relationships" id="258" r:id="R7eb2f739e432445a"/>
+    <p:sldId xmlns:r="http://schemas.openxmlformats.org/officeDocument/2006/relationships" id="259" r:id="Radba26d5f8e14500"/>
+    <p:sldId xmlns:r="http://schemas.openxmlformats.org/officeDocument/2006/relationships" id="260" r:id="Re6f4c8e6671246e8"/>
+    <p:sldId xmlns:r="http://schemas.openxmlformats.org/officeDocument/2006/relationships" id="261" r:id="R012e7cfd203a4c35"/>
+    <p:sldId xmlns:r="http://schemas.openxmlformats.org/officeDocument/2006/relationships" id="262" r:id="Rcba38dce71f44493"/>
+    <p:sldId xmlns:r="http://schemas.openxmlformats.org/officeDocument/2006/relationships" id="263" r:id="R3c679a70da8d4561"/>
+    <p:sldId xmlns:r="http://schemas.openxmlformats.org/officeDocument/2006/relationships" id="264" r:id="R47fedda725344b3e"/>
+    <p:sldId xmlns:r="http://schemas.openxmlformats.org/officeDocument/2006/relationships" id="265" r:id="Re894ed0c9f97434b"/>
+    <p:sldId xmlns:r="http://schemas.openxmlformats.org/officeDocument/2006/relationships" id="266" r:id="R8fe42322a62b45f0"/>
+    <p:sldId xmlns:r="http://schemas.openxmlformats.org/officeDocument/2006/relationships" id="267" r:id="Rcd1821cfbe4847ed"/>
+    <p:sldId xmlns:r="http://schemas.openxmlformats.org/officeDocument/2006/relationships" id="268" r:id="R565ffc51684f4117"/>
   </p:sldIdLst>
   <p:sldSz cx="12192000" cy="6858000"/>
   <p:notesSz cx="6858000" cy="9144000"/>
@@ -969,7 +969,7 @@
           <a:lstStyle xmlns:a="http://schemas.openxmlformats.org/drawingml/2006/main"/>
           <a:p xmlns:a="http://schemas.openxmlformats.org/drawingml/2006/main">
             <a:r>
-              <a:t>A local AI model moves the main work from a company data center onto a laptop, desktop, phone, or private computer that you control. It does not have to be permanently disconnected from the internet. The simple difference is where the answer is produced. If the model runs on your own device, it can work offline and sensitive files do not automatically need to be sent to an outside company.</a:t>
+              <a:t>If the model stays on your own device, it can work without an internet connection. Private files can remain on the computer instead of being uploaded for every request. You also avoid a cloud charge each time you ask a question, and simple repeated tasks may respond faster because the request does not travel to a data center. These benefits depend on the device and software. A weak laptop can still be slow, and privacy still depends on which apps or plugins are connected.</a:t>
             </a:r>
           </a:p>
           <a:p xmlns:a="http://schemas.openxmlformats.org/drawingml/2006/main">
@@ -984,7 +984,12 @@
           </a:p>
           <a:p xmlns:a="http://schemas.openxmlformats.org/drawingml/2006/main">
             <a:r>
-              <a:t>- Stock photo: Rahul Mishra, Unsplash — https://unsplash.com/photos/laptop-and-keyboard-on-a-dark-desk-BA2ELfOTqJ4</a:t>
+              <a:t>- Official photo: NVIDIA DGX Spark — https://nvidianews.nvidia.com/file/nvidia-dgx-spark?action=</a:t>
+            </a:r>
+          </a:p>
+          <a:p xmlns:a="http://schemas.openxmlformats.org/drawingml/2006/main">
+            <a:r>
+              <a:t>- NVIDIA DGX Spark product page — https://www.nvidia.com/en-us/products/workstations/dgx-spark/</a:t>
             </a:r>
           </a:p>
         </p:txBody>
@@ -1427,7 +1432,7 @@
   </p:cSld>
   <p:clrMap bg1="lt1" tx1="dk1" bg2="lt2" tx2="dk2" accent1="accent1" accent2="accent2" accent3="accent3" accent4="accent4" accent5="accent5" accent6="accent6" hlink="hlink" folHlink="folHlink"/>
   <p:sldLayoutIdLst>
-    <p:sldLayoutId xmlns:r="http://schemas.openxmlformats.org/officeDocument/2006/relationships" id="2147483649" r:id="Ra059161b52a2465c"/>
+    <p:sldLayoutId xmlns:r="http://schemas.openxmlformats.org/officeDocument/2006/relationships" id="2147483649" r:id="R76329de9bb444b25"/>
   </p:sldLayoutIdLst>
   <p:txStyles>
     <p:titleStyle>
@@ -2257,7 +2262,7 @@
           <p:cNvPr id="5" name="">
             <a:extLst xmlns:a="http://schemas.openxmlformats.org/drawingml/2006/main">
               <a:ext uri="{FF2B5EF4-FFF2-40B4-BE49-F238E27FC236}">
-                <a16:creationId xmlns:a16="http://schemas.microsoft.com/office/drawing/2014/main" id="{9F9BEC75-0D29-4434-8B65-5302CC217EE0}"/>
+                <a16:creationId xmlns:a16="http://schemas.microsoft.com/office/drawing/2014/main" id="{682DDEEB-59AF-4891-881D-5B2ECC4C8501}"/>
               </a:ext>
             </a:extLst>
           </p:cNvPr>
@@ -2345,7 +2350,7 @@
           <p:cNvPr id="2" name="">
             <a:extLst xmlns:a="http://schemas.openxmlformats.org/drawingml/2006/main">
               <a:ext uri="{FF2B5EF4-FFF2-40B4-BE49-F238E27FC236}">
-                <a16:creationId xmlns:a16="http://schemas.microsoft.com/office/drawing/2014/main" id="{CDE92ABF-CC1F-4606-8EA5-DB06B067F425}"/>
+                <a16:creationId xmlns:a16="http://schemas.microsoft.com/office/drawing/2014/main" id="{9F598CFF-17DF-4A28-9AF5-98E9B75CF6A8}"/>
               </a:ext>
             </a:extLst>
           </p:cNvPr>
@@ -2406,7 +2411,7 @@
           <p:cNvPr id="3" name="">
             <a:extLst xmlns:a="http://schemas.openxmlformats.org/drawingml/2006/main">
               <a:ext uri="{FF2B5EF4-FFF2-40B4-BE49-F238E27FC236}">
-                <a16:creationId xmlns:a16="http://schemas.microsoft.com/office/drawing/2014/main" id="{2ED11FBC-9E84-4F92-B57D-E332C029B4A7}"/>
+                <a16:creationId xmlns:a16="http://schemas.microsoft.com/office/drawing/2014/main" id="{34F99922-2759-48B3-9912-74B9E0B324F9}"/>
               </a:ext>
             </a:extLst>
           </p:cNvPr>
@@ -2437,7 +2442,7 @@
           <p:cNvPr id="4" name="">
             <a:extLst xmlns:a="http://schemas.openxmlformats.org/drawingml/2006/main">
               <a:ext uri="{FF2B5EF4-FFF2-40B4-BE49-F238E27FC236}">
-                <a16:creationId xmlns:a16="http://schemas.microsoft.com/office/drawing/2014/main" id="{92DDA847-2DFF-4C55-B523-11686F8FC0FF}"/>
+                <a16:creationId xmlns:a16="http://schemas.microsoft.com/office/drawing/2014/main" id="{C2F89EEE-1BD3-44EF-9D60-FAA451D006E3}"/>
               </a:ext>
             </a:extLst>
           </p:cNvPr>
@@ -2496,7 +2501,7 @@
     </p:spTree>
     <p:extLst>
       <p:ext uri="{BB962C8B-B14F-4D97-AF65-F5344CB8AC3E}">
-        <p14:creationId xmlns:p14="http://schemas.microsoft.com/office/powerpoint/2010/main" val="848580380"/>
+        <p14:creationId xmlns:p14="http://schemas.microsoft.com/office/powerpoint/2010/main" val="1539688086"/>
       </p:ext>
     </p:extLst>
   </p:cSld>
@@ -2527,7 +2532,7 @@
           <p:cNvPr id="6" name="">
             <a:extLst xmlns:a="http://schemas.openxmlformats.org/drawingml/2006/main">
               <a:ext uri="{FF2B5EF4-FFF2-40B4-BE49-F238E27FC236}">
-                <a16:creationId xmlns:a16="http://schemas.microsoft.com/office/drawing/2014/main" id="{6A5990F3-4FA7-40C8-8526-7A3F41943E60}"/>
+                <a16:creationId xmlns:a16="http://schemas.microsoft.com/office/drawing/2014/main" id="{0C1562EB-753A-4E01-A5C8-59A53680FB87}"/>
               </a:ext>
             </a:extLst>
           </p:cNvPr>
@@ -2588,7 +2593,7 @@
           <p:cNvPr id="2" name="">
             <a:extLst xmlns:a="http://schemas.openxmlformats.org/drawingml/2006/main">
               <a:ext uri="{FF2B5EF4-FFF2-40B4-BE49-F238E27FC236}">
-                <a16:creationId xmlns:a16="http://schemas.microsoft.com/office/drawing/2014/main" id="{299B1960-ECE1-4D85-A6B2-C3674313CA0B}"/>
+                <a16:creationId xmlns:a16="http://schemas.microsoft.com/office/drawing/2014/main" id="{34A52283-5132-40CD-9657-42643C27485C}"/>
               </a:ext>
             </a:extLst>
           </p:cNvPr>
@@ -2649,7 +2654,7 @@
           <p:cNvPr id="3" name="">
             <a:extLst xmlns:a="http://schemas.openxmlformats.org/drawingml/2006/main">
               <a:ext uri="{FF2B5EF4-FFF2-40B4-BE49-F238E27FC236}">
-                <a16:creationId xmlns:a16="http://schemas.microsoft.com/office/drawing/2014/main" id="{53DD31C5-C50D-4BE6-86DE-70EB6E02ACA8}"/>
+                <a16:creationId xmlns:a16="http://schemas.microsoft.com/office/drawing/2014/main" id="{00736A8E-92BC-40B5-A0A5-B0CDCEC5FEA4}"/>
               </a:ext>
             </a:extLst>
           </p:cNvPr>
@@ -2710,7 +2715,7 @@
           <p:cNvPr id="4" name="">
             <a:extLst xmlns:a="http://schemas.openxmlformats.org/drawingml/2006/main">
               <a:ext uri="{FF2B5EF4-FFF2-40B4-BE49-F238E27FC236}">
-                <a16:creationId xmlns:a16="http://schemas.microsoft.com/office/drawing/2014/main" id="{5915B425-2107-4351-91C8-D9A3BB6055EB}"/>
+                <a16:creationId xmlns:a16="http://schemas.microsoft.com/office/drawing/2014/main" id="{8F9DFBAC-FC0A-4A7A-AE45-BDA7694791E3}"/>
               </a:ext>
             </a:extLst>
           </p:cNvPr>
@@ -2798,7 +2803,7 @@
           <p:cNvPr id="5" name="">
             <a:extLst xmlns:a="http://schemas.openxmlformats.org/drawingml/2006/main">
               <a:ext uri="{FF2B5EF4-FFF2-40B4-BE49-F238E27FC236}">
-                <a16:creationId xmlns:a16="http://schemas.microsoft.com/office/drawing/2014/main" id="{E8DED0E2-1698-49E3-89B3-ABA946013497}"/>
+                <a16:creationId xmlns:a16="http://schemas.microsoft.com/office/drawing/2014/main" id="{16FDBE7B-5C04-415F-ABC7-101E9A1DF4BB}"/>
               </a:ext>
             </a:extLst>
           </p:cNvPr>
@@ -2857,7 +2862,7 @@
     </p:spTree>
     <p:extLst>
       <p:ext uri="{BB962C8B-B14F-4D97-AF65-F5344CB8AC3E}">
-        <p14:creationId xmlns:p14="http://schemas.microsoft.com/office/powerpoint/2010/main" val="485828582"/>
+        <p14:creationId xmlns:p14="http://schemas.microsoft.com/office/powerpoint/2010/main" val="338354140"/>
       </p:ext>
     </p:extLst>
   </p:cSld>
@@ -2888,7 +2893,7 @@
           <p:cNvPr id="5" name="">
             <a:extLst xmlns:a="http://schemas.openxmlformats.org/drawingml/2006/main">
               <a:ext uri="{FF2B5EF4-FFF2-40B4-BE49-F238E27FC236}">
-                <a16:creationId xmlns:a16="http://schemas.microsoft.com/office/drawing/2014/main" id="{4BF7FB77-0A1A-4D8B-B53D-7AA91EF19774}"/>
+                <a16:creationId xmlns:a16="http://schemas.microsoft.com/office/drawing/2014/main" id="{A8882EF7-BE56-4F97-B84B-B618EBF8C4F5}"/>
               </a:ext>
             </a:extLst>
           </p:cNvPr>
@@ -2949,7 +2954,7 @@
           <p:cNvPr id="2" name="">
             <a:extLst xmlns:a="http://schemas.openxmlformats.org/drawingml/2006/main">
               <a:ext uri="{FF2B5EF4-FFF2-40B4-BE49-F238E27FC236}">
-                <a16:creationId xmlns:a16="http://schemas.microsoft.com/office/drawing/2014/main" id="{66B87B11-66C3-49CB-8EBE-E931471B971C}"/>
+                <a16:creationId xmlns:a16="http://schemas.microsoft.com/office/drawing/2014/main" id="{DB23DF4F-F465-4911-B793-D97128310DAF}"/>
               </a:ext>
             </a:extLst>
           </p:cNvPr>
@@ -3010,7 +3015,7 @@
           <p:cNvPr id="3" name="">
             <a:extLst xmlns:a="http://schemas.openxmlformats.org/drawingml/2006/main">
               <a:ext uri="{FF2B5EF4-FFF2-40B4-BE49-F238E27FC236}">
-                <a16:creationId xmlns:a16="http://schemas.microsoft.com/office/drawing/2014/main" id="{D9E4842D-C003-4272-B0BA-35EDE1E23B63}"/>
+                <a16:creationId xmlns:a16="http://schemas.microsoft.com/office/drawing/2014/main" id="{5F00A885-F58D-44D6-9249-E5EE7BE7B774}"/>
               </a:ext>
             </a:extLst>
           </p:cNvPr>
@@ -3125,7 +3130,7 @@
           <p:cNvPr id="4" name="">
             <a:extLst xmlns:a="http://schemas.openxmlformats.org/drawingml/2006/main">
               <a:ext uri="{FF2B5EF4-FFF2-40B4-BE49-F238E27FC236}">
-                <a16:creationId xmlns:a16="http://schemas.microsoft.com/office/drawing/2014/main" id="{3351D836-AB6C-4B1A-8B4A-BAA8661C4AAA}"/>
+                <a16:creationId xmlns:a16="http://schemas.microsoft.com/office/drawing/2014/main" id="{2B0C5093-9BD6-406B-A16F-211B4CEB7173}"/>
               </a:ext>
             </a:extLst>
           </p:cNvPr>
@@ -3184,7 +3189,7 @@
     </p:spTree>
     <p:extLst>
       <p:ext uri="{BB962C8B-B14F-4D97-AF65-F5344CB8AC3E}">
-        <p14:creationId xmlns:p14="http://schemas.microsoft.com/office/powerpoint/2010/main" val="1907119189"/>
+        <p14:creationId xmlns:p14="http://schemas.microsoft.com/office/powerpoint/2010/main" val="792893701"/>
       </p:ext>
     </p:extLst>
   </p:cSld>
@@ -3215,7 +3220,7 @@
           <p:cNvPr id="9" name="">
             <a:extLst xmlns:a="http://schemas.openxmlformats.org/drawingml/2006/main">
               <a:ext uri="{FF2B5EF4-FFF2-40B4-BE49-F238E27FC236}">
-                <a16:creationId xmlns:a16="http://schemas.microsoft.com/office/drawing/2014/main" id="{95935E0A-B534-436D-BC3C-7CA831A9CC8D}"/>
+                <a16:creationId xmlns:a16="http://schemas.microsoft.com/office/drawing/2014/main" id="{EEC7CA3A-5196-4D73-ACFE-916AD7757D24}"/>
               </a:ext>
             </a:extLst>
           </p:cNvPr>
@@ -3276,7 +3281,7 @@
           <p:cNvPr id="2" name="">
             <a:extLst xmlns:a="http://schemas.openxmlformats.org/drawingml/2006/main">
               <a:ext uri="{FF2B5EF4-FFF2-40B4-BE49-F238E27FC236}">
-                <a16:creationId xmlns:a16="http://schemas.microsoft.com/office/drawing/2014/main" id="{3DB3C64B-0D86-4AEB-A2B3-AF8F02FA7BCB}"/>
+                <a16:creationId xmlns:a16="http://schemas.microsoft.com/office/drawing/2014/main" id="{311C2376-5A6B-4157-9CB8-97BB648B0784}"/>
               </a:ext>
             </a:extLst>
           </p:cNvPr>
@@ -3337,7 +3342,7 @@
           <p:cNvPr id="3" name="">
             <a:extLst xmlns:a="http://schemas.openxmlformats.org/drawingml/2006/main">
               <a:ext uri="{FF2B5EF4-FFF2-40B4-BE49-F238E27FC236}">
-                <a16:creationId xmlns:a16="http://schemas.microsoft.com/office/drawing/2014/main" id="{AB512D47-19FE-4E9C-9534-330BE789B262}"/>
+                <a16:creationId xmlns:a16="http://schemas.microsoft.com/office/drawing/2014/main" id="{9061841B-89B2-4278-92EE-F836441D9873}"/>
               </a:ext>
             </a:extLst>
           </p:cNvPr>
@@ -3398,7 +3403,7 @@
           <p:cNvPr id="4" name="">
             <a:extLst xmlns:a="http://schemas.openxmlformats.org/drawingml/2006/main">
               <a:ext uri="{FF2B5EF4-FFF2-40B4-BE49-F238E27FC236}">
-                <a16:creationId xmlns:a16="http://schemas.microsoft.com/office/drawing/2014/main" id="{E49E4F02-A4F7-4035-9D36-87CAC0348B1C}"/>
+                <a16:creationId xmlns:a16="http://schemas.microsoft.com/office/drawing/2014/main" id="{3DAC5DE2-E48A-4226-9DE3-DF897A3D85AB}"/>
               </a:ext>
             </a:extLst>
           </p:cNvPr>
@@ -3429,7 +3434,7 @@
           <p:cNvPr id="5" name="">
             <a:extLst xmlns:a="http://schemas.openxmlformats.org/drawingml/2006/main">
               <a:ext uri="{FF2B5EF4-FFF2-40B4-BE49-F238E27FC236}">
-                <a16:creationId xmlns:a16="http://schemas.microsoft.com/office/drawing/2014/main" id="{E84DB9FA-5D10-44FD-8B22-1158C0E2A415}"/>
+                <a16:creationId xmlns:a16="http://schemas.microsoft.com/office/drawing/2014/main" id="{87ADE52C-442C-440F-B2CC-339031F4D561}"/>
               </a:ext>
             </a:extLst>
           </p:cNvPr>
@@ -3517,7 +3522,7 @@
           <p:cNvPr id="6" name="">
             <a:extLst xmlns:a="http://schemas.openxmlformats.org/drawingml/2006/main">
               <a:ext uri="{FF2B5EF4-FFF2-40B4-BE49-F238E27FC236}">
-                <a16:creationId xmlns:a16="http://schemas.microsoft.com/office/drawing/2014/main" id="{663EA3F8-50D0-42C7-9CE1-E0E9F7E0BA81}"/>
+                <a16:creationId xmlns:a16="http://schemas.microsoft.com/office/drawing/2014/main" id="{9220A7B7-5980-4B23-914A-778F2BF1AA9B}"/>
               </a:ext>
             </a:extLst>
           </p:cNvPr>
@@ -3548,7 +3553,7 @@
           <p:cNvPr id="7" name="">
             <a:extLst xmlns:a="http://schemas.openxmlformats.org/drawingml/2006/main">
               <a:ext uri="{FF2B5EF4-FFF2-40B4-BE49-F238E27FC236}">
-                <a16:creationId xmlns:a16="http://schemas.microsoft.com/office/drawing/2014/main" id="{DACC85C5-0B08-4E46-B429-D0CC66240D35}"/>
+                <a16:creationId xmlns:a16="http://schemas.microsoft.com/office/drawing/2014/main" id="{26B5807E-F844-4277-A7BF-46C212BC8F1F}"/>
               </a:ext>
             </a:extLst>
           </p:cNvPr>
@@ -3609,7 +3614,7 @@
           <p:cNvPr id="8" name="">
             <a:extLst xmlns:a="http://schemas.openxmlformats.org/drawingml/2006/main">
               <a:ext uri="{FF2B5EF4-FFF2-40B4-BE49-F238E27FC236}">
-                <a16:creationId xmlns:a16="http://schemas.microsoft.com/office/drawing/2014/main" id="{CAB10F1B-B5DD-42CA-90B8-04B27085599D}"/>
+                <a16:creationId xmlns:a16="http://schemas.microsoft.com/office/drawing/2014/main" id="{067F6402-5C88-4C82-8E23-C63B486708B7}"/>
               </a:ext>
             </a:extLst>
           </p:cNvPr>
@@ -3668,7 +3673,7 @@
     </p:spTree>
     <p:extLst>
       <p:ext uri="{BB962C8B-B14F-4D97-AF65-F5344CB8AC3E}">
-        <p14:creationId xmlns:p14="http://schemas.microsoft.com/office/powerpoint/2010/main" val="1064338339"/>
+        <p14:creationId xmlns:p14="http://schemas.microsoft.com/office/powerpoint/2010/main" val="1655308722"/>
       </p:ext>
     </p:extLst>
   </p:cSld>
@@ -3699,7 +3704,7 @@
           <p:cNvPr id="7" name="">
             <a:extLst xmlns:a="http://schemas.openxmlformats.org/drawingml/2006/main">
               <a:ext uri="{FF2B5EF4-FFF2-40B4-BE49-F238E27FC236}">
-                <a16:creationId xmlns:a16="http://schemas.microsoft.com/office/drawing/2014/main" id="{CD02D495-3DBE-4314-8FF9-82D58338ED7B}"/>
+                <a16:creationId xmlns:a16="http://schemas.microsoft.com/office/drawing/2014/main" id="{AFE0D27F-C6E5-4C8F-8D2F-FBE13C527489}"/>
               </a:ext>
             </a:extLst>
           </p:cNvPr>
@@ -3787,7 +3792,7 @@
           <p:cNvPr id="2" name="">
             <a:extLst xmlns:a="http://schemas.openxmlformats.org/drawingml/2006/main">
               <a:ext uri="{FF2B5EF4-FFF2-40B4-BE49-F238E27FC236}">
-                <a16:creationId xmlns:a16="http://schemas.microsoft.com/office/drawing/2014/main" id="{D5084668-03AE-4F59-AE79-B3AA68723160}"/>
+                <a16:creationId xmlns:a16="http://schemas.microsoft.com/office/drawing/2014/main" id="{988B0D8C-C6C8-4E75-B190-FF56D49EF15B}"/>
               </a:ext>
             </a:extLst>
           </p:cNvPr>
@@ -3848,7 +3853,7 @@
           <p:cNvPr id="3" name="">
             <a:extLst xmlns:a="http://schemas.openxmlformats.org/drawingml/2006/main">
               <a:ext uri="{FF2B5EF4-FFF2-40B4-BE49-F238E27FC236}">
-                <a16:creationId xmlns:a16="http://schemas.microsoft.com/office/drawing/2014/main" id="{78CF6D6A-1FCC-48D6-8FE5-6DADD7B31821}"/>
+                <a16:creationId xmlns:a16="http://schemas.microsoft.com/office/drawing/2014/main" id="{2BC7B6B4-FAD3-4D43-919F-169615DD95E5}"/>
               </a:ext>
             </a:extLst>
           </p:cNvPr>
@@ -3879,7 +3884,7 @@
           <p:cNvPr id="4" name="">
             <a:extLst xmlns:a="http://schemas.openxmlformats.org/drawingml/2006/main">
               <a:ext uri="{FF2B5EF4-FFF2-40B4-BE49-F238E27FC236}">
-                <a16:creationId xmlns:a16="http://schemas.microsoft.com/office/drawing/2014/main" id="{21A2A303-663B-4B96-AD26-DD357E3881DB}"/>
+                <a16:creationId xmlns:a16="http://schemas.microsoft.com/office/drawing/2014/main" id="{8C70D0BE-3001-4537-AA1D-88C26FCE8B31}"/>
               </a:ext>
             </a:extLst>
           </p:cNvPr>
@@ -3940,7 +3945,7 @@
           <p:cNvPr id="5" name="">
             <a:extLst xmlns:a="http://schemas.openxmlformats.org/drawingml/2006/main">
               <a:ext uri="{FF2B5EF4-FFF2-40B4-BE49-F238E27FC236}">
-                <a16:creationId xmlns:a16="http://schemas.microsoft.com/office/drawing/2014/main" id="{6A0F9598-71E8-40BA-9412-6011CE829ECC}"/>
+                <a16:creationId xmlns:a16="http://schemas.microsoft.com/office/drawing/2014/main" id="{EDFD2559-340C-4634-B270-9F3E3A8843C2}"/>
               </a:ext>
             </a:extLst>
           </p:cNvPr>
@@ -4001,7 +4006,7 @@
           <p:cNvPr id="6" name="">
             <a:extLst xmlns:a="http://schemas.openxmlformats.org/drawingml/2006/main">
               <a:ext uri="{FF2B5EF4-FFF2-40B4-BE49-F238E27FC236}">
-                <a16:creationId xmlns:a16="http://schemas.microsoft.com/office/drawing/2014/main" id="{1B359905-A862-4B90-A24B-6B7EE90E985D}"/>
+                <a16:creationId xmlns:a16="http://schemas.microsoft.com/office/drawing/2014/main" id="{86EB4BB9-9BF5-4DC5-A5B3-757EDF931329}"/>
               </a:ext>
             </a:extLst>
           </p:cNvPr>
@@ -4060,7 +4065,7 @@
     </p:spTree>
     <p:extLst>
       <p:ext uri="{BB962C8B-B14F-4D97-AF65-F5344CB8AC3E}">
-        <p14:creationId xmlns:p14="http://schemas.microsoft.com/office/powerpoint/2010/main" val="463410090"/>
+        <p14:creationId xmlns:p14="http://schemas.microsoft.com/office/powerpoint/2010/main" val="250888838"/>
       </p:ext>
     </p:extLst>
   </p:cSld>
@@ -4091,7 +4096,7 @@
           <p:cNvPr id="7" name="">
             <a:extLst xmlns:a="http://schemas.openxmlformats.org/drawingml/2006/main">
               <a:ext uri="{FF2B5EF4-FFF2-40B4-BE49-F238E27FC236}">
-                <a16:creationId xmlns:a16="http://schemas.microsoft.com/office/drawing/2014/main" id="{81BCDF03-B553-4C6A-B865-4332A4314C58}"/>
+                <a16:creationId xmlns:a16="http://schemas.microsoft.com/office/drawing/2014/main" id="{D32714DF-FC78-4F42-A86A-6B522CE2298C}"/>
               </a:ext>
             </a:extLst>
           </p:cNvPr>
@@ -4152,7 +4157,7 @@
           <p:cNvPr id="2" name="">
             <a:extLst xmlns:a="http://schemas.openxmlformats.org/drawingml/2006/main">
               <a:ext uri="{FF2B5EF4-FFF2-40B4-BE49-F238E27FC236}">
-                <a16:creationId xmlns:a16="http://schemas.microsoft.com/office/drawing/2014/main" id="{5AC6C98B-3D95-4345-96D4-103B65EEAF15}"/>
+                <a16:creationId xmlns:a16="http://schemas.microsoft.com/office/drawing/2014/main" id="{A85C32D0-E355-4187-B9F8-5452A113036E}"/>
               </a:ext>
             </a:extLst>
           </p:cNvPr>
@@ -4217,7 +4222,7 @@
           <p:nvPr/>
         </p:nvPicPr>
         <p:blipFill>
-          <a:blip xmlns:r="http://schemas.openxmlformats.org/officeDocument/2006/relationships" xmlns:a="http://schemas.openxmlformats.org/drawingml/2006/main" r:embed="R64d4a785732e412d"/>
+          <a:blip xmlns:r="http://schemas.openxmlformats.org/officeDocument/2006/relationships" xmlns:a="http://schemas.openxmlformats.org/drawingml/2006/main" r:embed="R346cfb3b2cd9432a"/>
           <a:stretch xmlns:a="http://schemas.openxmlformats.org/drawingml/2006/main"/>
         </p:blipFill>
         <p:spPr>
@@ -4239,7 +4244,7 @@
           <p:nvPr/>
         </p:nvPicPr>
         <p:blipFill>
-          <a:blip xmlns:r="http://schemas.openxmlformats.org/officeDocument/2006/relationships" xmlns:a="http://schemas.openxmlformats.org/drawingml/2006/main" r:embed="R9f4c4931e3884c1d"/>
+          <a:blip xmlns:r="http://schemas.openxmlformats.org/officeDocument/2006/relationships" xmlns:a="http://schemas.openxmlformats.org/drawingml/2006/main" r:embed="R4874b09f70e74322"/>
           <a:stretch xmlns:a="http://schemas.openxmlformats.org/drawingml/2006/main"/>
         </p:blipFill>
         <p:spPr>
@@ -4257,7 +4262,7 @@
           <p:cNvPr id="5" name="">
             <a:extLst xmlns:a="http://schemas.openxmlformats.org/drawingml/2006/main">
               <a:ext uri="{FF2B5EF4-FFF2-40B4-BE49-F238E27FC236}">
-                <a16:creationId xmlns:a16="http://schemas.microsoft.com/office/drawing/2014/main" id="{D3604F9A-86B2-4E93-8057-06D8673F212F}"/>
+                <a16:creationId xmlns:a16="http://schemas.microsoft.com/office/drawing/2014/main" id="{F571D127-86EB-461B-AA65-F3F3E4830239}"/>
               </a:ext>
             </a:extLst>
           </p:cNvPr>
@@ -4318,7 +4323,7 @@
           <p:cNvPr id="6" name="">
             <a:extLst xmlns:a="http://schemas.openxmlformats.org/drawingml/2006/main">
               <a:ext uri="{FF2B5EF4-FFF2-40B4-BE49-F238E27FC236}">
-                <a16:creationId xmlns:a16="http://schemas.microsoft.com/office/drawing/2014/main" id="{44674717-D173-4318-BEB6-F2E22D4D5ECB}"/>
+                <a16:creationId xmlns:a16="http://schemas.microsoft.com/office/drawing/2014/main" id="{3D9E8488-E8C9-4FA7-933B-C9125744EE98}"/>
               </a:ext>
             </a:extLst>
           </p:cNvPr>
@@ -4377,7 +4382,7 @@
     </p:spTree>
     <p:extLst>
       <p:ext uri="{BB962C8B-B14F-4D97-AF65-F5344CB8AC3E}">
-        <p14:creationId xmlns:p14="http://schemas.microsoft.com/office/powerpoint/2010/main" val="418647612"/>
+        <p14:creationId xmlns:p14="http://schemas.microsoft.com/office/powerpoint/2010/main" val="654863258"/>
       </p:ext>
     </p:extLst>
   </p:cSld>
@@ -4408,7 +4413,7 @@
           <p:cNvPr id="9" name="">
             <a:extLst xmlns:a="http://schemas.openxmlformats.org/drawingml/2006/main">
               <a:ext uri="{FF2B5EF4-FFF2-40B4-BE49-F238E27FC236}">
-                <a16:creationId xmlns:a16="http://schemas.microsoft.com/office/drawing/2014/main" id="{0900539C-0419-40DE-B07F-A3164FC7C43C}"/>
+                <a16:creationId xmlns:a16="http://schemas.microsoft.com/office/drawing/2014/main" id="{01EA762B-21DE-4FAD-A772-0DD15FC253DB}"/>
               </a:ext>
             </a:extLst>
           </p:cNvPr>
@@ -4469,7 +4474,7 @@
           <p:cNvPr id="2" name="">
             <a:extLst xmlns:a="http://schemas.openxmlformats.org/drawingml/2006/main">
               <a:ext uri="{FF2B5EF4-FFF2-40B4-BE49-F238E27FC236}">
-                <a16:creationId xmlns:a16="http://schemas.microsoft.com/office/drawing/2014/main" id="{7CDF5FC0-1B44-4848-AA13-FD300EF0ABD2}"/>
+                <a16:creationId xmlns:a16="http://schemas.microsoft.com/office/drawing/2014/main" id="{FCA332BC-F102-480B-8DA7-44CA9497546D}"/>
               </a:ext>
             </a:extLst>
           </p:cNvPr>
@@ -4530,7 +4535,7 @@
           <p:cNvPr id="3" name="">
             <a:extLst xmlns:a="http://schemas.openxmlformats.org/drawingml/2006/main">
               <a:ext uri="{FF2B5EF4-FFF2-40B4-BE49-F238E27FC236}">
-                <a16:creationId xmlns:a16="http://schemas.microsoft.com/office/drawing/2014/main" id="{25ED2EB7-C9E4-4BD9-A387-5F7AF01E3BEB}"/>
+                <a16:creationId xmlns:a16="http://schemas.microsoft.com/office/drawing/2014/main" id="{9F07D349-C7C1-4A68-9C60-1D9EE44D8769}"/>
               </a:ext>
             </a:extLst>
           </p:cNvPr>
@@ -4591,7 +4596,7 @@
           <p:cNvPr id="4" name="">
             <a:extLst xmlns:a="http://schemas.openxmlformats.org/drawingml/2006/main">
               <a:ext uri="{FF2B5EF4-FFF2-40B4-BE49-F238E27FC236}">
-                <a16:creationId xmlns:a16="http://schemas.microsoft.com/office/drawing/2014/main" id="{2DA3E0F8-49F2-4D35-8A26-B5943BEB5CFF}"/>
+                <a16:creationId xmlns:a16="http://schemas.microsoft.com/office/drawing/2014/main" id="{9C9359AE-5EE0-4059-8497-A2C32C8EC525}"/>
               </a:ext>
             </a:extLst>
           </p:cNvPr>
@@ -4652,7 +4657,7 @@
           <p:cNvPr id="5" name="">
             <a:extLst xmlns:a="http://schemas.openxmlformats.org/drawingml/2006/main">
               <a:ext uri="{FF2B5EF4-FFF2-40B4-BE49-F238E27FC236}">
-                <a16:creationId xmlns:a16="http://schemas.microsoft.com/office/drawing/2014/main" id="{077435D0-D6C2-4E9C-8661-EA4DAD3B4117}"/>
+                <a16:creationId xmlns:a16="http://schemas.microsoft.com/office/drawing/2014/main" id="{AB271474-225F-4D83-B710-6F14443480FC}"/>
               </a:ext>
             </a:extLst>
           </p:cNvPr>
@@ -4713,7 +4718,7 @@
           <p:cNvPr id="6" name="">
             <a:extLst xmlns:a="http://schemas.openxmlformats.org/drawingml/2006/main">
               <a:ext uri="{FF2B5EF4-FFF2-40B4-BE49-F238E27FC236}">
-                <a16:creationId xmlns:a16="http://schemas.microsoft.com/office/drawing/2014/main" id="{F7CFDA3E-90DB-4850-AB19-C9A2616F330D}"/>
+                <a16:creationId xmlns:a16="http://schemas.microsoft.com/office/drawing/2014/main" id="{BE5D868A-2948-4B84-9A46-B0989B7A4609}"/>
               </a:ext>
             </a:extLst>
           </p:cNvPr>
@@ -4744,7 +4749,7 @@
           <p:cNvPr id="7" name="">
             <a:extLst xmlns:a="http://schemas.openxmlformats.org/drawingml/2006/main">
               <a:ext uri="{FF2B5EF4-FFF2-40B4-BE49-F238E27FC236}">
-                <a16:creationId xmlns:a16="http://schemas.microsoft.com/office/drawing/2014/main" id="{BC9F4371-A92E-486A-BDF1-9FA3ED2F362D}"/>
+                <a16:creationId xmlns:a16="http://schemas.microsoft.com/office/drawing/2014/main" id="{E96C6215-171C-4C78-92E5-9897E0F083F4}"/>
               </a:ext>
             </a:extLst>
           </p:cNvPr>
@@ -4775,7 +4780,7 @@
           <p:cNvPr id="8" name="">
             <a:extLst xmlns:a="http://schemas.openxmlformats.org/drawingml/2006/main">
               <a:ext uri="{FF2B5EF4-FFF2-40B4-BE49-F238E27FC236}">
-                <a16:creationId xmlns:a16="http://schemas.microsoft.com/office/drawing/2014/main" id="{B1B3A5B3-084A-4227-AA4B-B9DA781FA77C}"/>
+                <a16:creationId xmlns:a16="http://schemas.microsoft.com/office/drawing/2014/main" id="{656D69A7-9EB2-4B3D-A838-184B6E2E666F}"/>
               </a:ext>
             </a:extLst>
           </p:cNvPr>
@@ -4834,7 +4839,7 @@
     </p:spTree>
     <p:extLst>
       <p:ext uri="{BB962C8B-B14F-4D97-AF65-F5344CB8AC3E}">
-        <p14:creationId xmlns:p14="http://schemas.microsoft.com/office/powerpoint/2010/main" val="42043473"/>
+        <p14:creationId xmlns:p14="http://schemas.microsoft.com/office/powerpoint/2010/main" val="1757712423"/>
       </p:ext>
     </p:extLst>
   </p:cSld>
@@ -4862,10 +4867,10 @@
       </p:grpSpPr>
       <p:sp>
         <p:nvSpPr>
-          <p:cNvPr id="6" name="">
+          <p:cNvPr id="7" name="">
             <a:extLst xmlns:a="http://schemas.openxmlformats.org/drawingml/2006/main">
               <a:ext uri="{FF2B5EF4-FFF2-40B4-BE49-F238E27FC236}">
-                <a16:creationId xmlns:a16="http://schemas.microsoft.com/office/drawing/2014/main" id="{B59AD6E1-C9A9-422B-9F61-D33051237F0A}"/>
+                <a16:creationId xmlns:a16="http://schemas.microsoft.com/office/drawing/2014/main" id="{4E2C3B48-9038-4518-8577-21EF243516D7}"/>
               </a:ext>
             </a:extLst>
           </p:cNvPr>
@@ -4926,7 +4931,7 @@
           <p:cNvPr id="2" name="">
             <a:extLst xmlns:a="http://schemas.openxmlformats.org/drawingml/2006/main">
               <a:ext uri="{FF2B5EF4-FFF2-40B4-BE49-F238E27FC236}">
-                <a16:creationId xmlns:a16="http://schemas.microsoft.com/office/drawing/2014/main" id="{6ABA26CC-84C3-44D5-A28C-A0D5534BD405}"/>
+                <a16:creationId xmlns:a16="http://schemas.microsoft.com/office/drawing/2014/main" id="{AA9BD1E0-7A48-4526-BF76-41D38EFB8169}"/>
               </a:ext>
             </a:extLst>
           </p:cNvPr>
@@ -4987,7 +4992,7 @@
           <p:cNvPr id="3" name="">
             <a:extLst xmlns:a="http://schemas.openxmlformats.org/drawingml/2006/main">
               <a:ext uri="{FF2B5EF4-FFF2-40B4-BE49-F238E27FC236}">
-                <a16:creationId xmlns:a16="http://schemas.microsoft.com/office/drawing/2014/main" id="{B8B202FC-8D86-4E54-9F8A-5F7BB1595F64}"/>
+                <a16:creationId xmlns:a16="http://schemas.microsoft.com/office/drawing/2014/main" id="{D1545B00-E0D6-40A1-BE71-7A3AC59DD25E}"/>
               </a:ext>
             </a:extLst>
           </p:cNvPr>
@@ -4998,8 +5003,8 @@
         </p:nvSpPr>
         <p:spPr>
           <a:xfrm xmlns:a="http://schemas.openxmlformats.org/drawingml/2006/main">
-            <a:off x="666750" y="1952625"/>
-            <a:ext cx="4762500" cy="1123950"/>
+            <a:off x="685800" y="1714500"/>
+            <a:ext cx="4762500" cy="3714750"/>
           </a:xfrm>
           <a:prstGeom xmlns:a="http://schemas.openxmlformats.org/drawingml/2006/main" prst="rect">
             <a:avLst/>
@@ -5010,27 +5015,36 @@
           </a:ln>
         </p:spPr>
         <p:txBody>
-          <a:bodyPr xmlns:a="http://schemas.openxmlformats.org/drawingml/2006/main" wrap="square" lIns="0" tIns="0" rIns="0" bIns="0" anchor="t">
-            <a:normAutofit fontScale="100000"/>
-          </a:bodyPr>
-          <a:lstStyle xmlns:a="http://schemas.openxmlformats.org/drawingml/2006/main"/>
-          <a:p xmlns:a="http://schemas.openxmlformats.org/drawingml/2006/main">
-            <a:pPr algn="l">
-              <a:lnSpc>
-                <a:spcPct val="102000"/>
-              </a:lnSpc>
-              <a:buNone/>
-              <a:defRPr sz="3000" b="1">
+          <a:bodyPr xmlns:a="http://schemas.openxmlformats.org/drawingml/2006/main"/>
+          <a:lstStyle xmlns:a="http://schemas.openxmlformats.org/drawingml/2006/main"/>
+          <a:p xmlns:a="http://schemas.openxmlformats.org/drawingml/2006/main">
+            <a:pPr marL="279400" indent="-139700">
+              <a:spcAft>
+                <a:spcPts val="2000"/>
+              </a:spcAft>
+              <a:buChar char="•"/>
+            </a:pPr>
+            <a:r>
+              <a:rPr sz="2250">
                 <a:solidFill>
                   <a:srgbClr val="101114"/>
                 </a:solidFill>
                 <a:latin typeface="Helvetica Neue"/>
                 <a:ea typeface="Helvetica Neue"/>
                 <a:cs typeface="Helvetica Neue"/>
-              </a:defRPr>
-            </a:pPr>
-            <a:r>
-              <a:rPr sz="3000" b="1">
+              </a:rPr>
+              <a:t>No internet connection required</a:t>
+            </a:r>
+          </a:p>
+          <a:p xmlns:a="http://schemas.openxmlformats.org/drawingml/2006/main">
+            <a:pPr marL="279400" indent="-139700">
+              <a:spcAft>
+                <a:spcPts val="2000"/>
+              </a:spcAft>
+              <a:buChar char="•"/>
+            </a:pPr>
+            <a:r>
+              <a:rPr sz="2250">
                 <a:solidFill>
                   <a:srgbClr val="101114"/>
                 </a:solidFill>
@@ -5038,68 +5052,45 @@
                 <a:ea typeface="Helvetica Neue"/>
                 <a:cs typeface="Helvetica Neue"/>
               </a:rPr>
-              <a:t>AI can run on a device you control.</a:t>
-            </a:r>
-          </a:p>
-        </p:txBody>
-      </p:sp>
-      <p:sp>
-        <p:nvSpPr>
-          <p:cNvPr id="4" name="">
-            <a:extLst xmlns:a="http://schemas.openxmlformats.org/drawingml/2006/main">
-              <a:ext uri="{FF2B5EF4-FFF2-40B4-BE49-F238E27FC236}">
-                <a16:creationId xmlns:a16="http://schemas.microsoft.com/office/drawing/2014/main" id="{FC8E127E-790E-4279-87C2-2C1C07FAB3E6}"/>
-              </a:ext>
-            </a:extLst>
-          </p:cNvPr>
-          <p:cNvSpPr>
-            <a:spLocks xmlns:a="http://schemas.openxmlformats.org/drawingml/2006/main" noGrp="1"/>
-          </p:cNvSpPr>
-          <p:nvPr/>
-        </p:nvSpPr>
-        <p:spPr>
-          <a:xfrm xmlns:a="http://schemas.openxmlformats.org/drawingml/2006/main">
-            <a:off x="666750" y="3619500"/>
-            <a:ext cx="4381500" cy="552450"/>
-          </a:xfrm>
-          <a:prstGeom xmlns:a="http://schemas.openxmlformats.org/drawingml/2006/main" prst="rect">
-            <a:avLst/>
-          </a:prstGeom>
-          <a:noFill xmlns:a="http://schemas.openxmlformats.org/drawingml/2006/main"/>
-          <a:ln xmlns:a="http://schemas.openxmlformats.org/drawingml/2006/main" w="0">
-            <a:noFill/>
-          </a:ln>
-        </p:spPr>
-        <p:txBody>
-          <a:bodyPr xmlns:a="http://schemas.openxmlformats.org/drawingml/2006/main" wrap="square" lIns="0" tIns="0" rIns="0" bIns="0" anchor="t">
-            <a:normAutofit fontScale="100000"/>
-          </a:bodyPr>
-          <a:lstStyle xmlns:a="http://schemas.openxmlformats.org/drawingml/2006/main"/>
-          <a:p xmlns:a="http://schemas.openxmlformats.org/drawingml/2006/main">
-            <a:pPr algn="l">
-              <a:lnSpc>
-                <a:spcPct val="100000"/>
-              </a:lnSpc>
-              <a:buNone/>
-              <a:defRPr sz="2025" b="0">
-                <a:solidFill>
-                  <a:srgbClr val="74716C"/>
-                </a:solidFill>
-                <a:latin typeface="Helvetica Neue"/>
-                <a:ea typeface="Helvetica Neue"/>
-                <a:cs typeface="Helvetica Neue"/>
-              </a:defRPr>
-            </a:pPr>
-            <a:r>
-              <a:rPr sz="2025" b="0">
-                <a:solidFill>
-                  <a:srgbClr val="74716C"/>
-                </a:solidFill>
-                <a:latin typeface="Helvetica Neue"/>
-                <a:ea typeface="Helvetica Neue"/>
-                <a:cs typeface="Helvetica Neue"/>
-              </a:rPr>
-              <a:t>No Wi-Fi required.</a:t>
+              <a:t>Private files stay on your device</a:t>
+            </a:r>
+          </a:p>
+          <a:p xmlns:a="http://schemas.openxmlformats.org/drawingml/2006/main">
+            <a:pPr marL="279400" indent="-139700">
+              <a:spcAft>
+                <a:spcPts val="2000"/>
+              </a:spcAft>
+              <a:buChar char="•"/>
+            </a:pPr>
+            <a:r>
+              <a:rPr sz="2250">
+                <a:solidFill>
+                  <a:srgbClr val="101114"/>
+                </a:solidFill>
+                <a:latin typeface="Helvetica Neue"/>
+                <a:ea typeface="Helvetica Neue"/>
+                <a:cs typeface="Helvetica Neue"/>
+              </a:rPr>
+              <a:t>No cloud bill per question</a:t>
+            </a:r>
+          </a:p>
+          <a:p xmlns:a="http://schemas.openxmlformats.org/drawingml/2006/main">
+            <a:pPr marL="279400" indent="-139700">
+              <a:spcAft>
+                <a:spcPts val="2000"/>
+              </a:spcAft>
+              <a:buChar char="•"/>
+            </a:pPr>
+            <a:r>
+              <a:rPr sz="2250">
+                <a:solidFill>
+                  <a:srgbClr val="101114"/>
+                </a:solidFill>
+                <a:latin typeface="Helvetica Neue"/>
+                <a:ea typeface="Helvetica Neue"/>
+                <a:cs typeface="Helvetica Neue"/>
+              </a:rPr>
+              <a:t>Faster for routine tasks</a:t>
             </a:r>
           </a:p>
         </p:txBody>
@@ -5113,26 +5104,145 @@
           <p:nvPr/>
         </p:nvPicPr>
         <p:blipFill>
-          <a:blip xmlns:r="http://schemas.openxmlformats.org/officeDocument/2006/relationships" xmlns:a="http://schemas.openxmlformats.org/drawingml/2006/main" r:embed="R891e9c747766412e"/>
-          <a:srcRect xmlns:a="http://schemas.openxmlformats.org/drawingml/2006/main" l="10357" t="0" r="10357" b="0"/>
-          <a:stretch xmlns:a="http://schemas.openxmlformats.org/drawingml/2006/main">
-            <a:fillRect l="0" t="0" r="0" b="0"/>
-          </a:stretch>
+          <a:blip xmlns:r="http://schemas.openxmlformats.org/officeDocument/2006/relationships" xmlns:a="http://schemas.openxmlformats.org/drawingml/2006/main" r:embed="R53f41f50fed94bca"/>
+          <a:stretch xmlns:a="http://schemas.openxmlformats.org/drawingml/2006/main"/>
         </p:blipFill>
         <p:spPr>
           <a:xfrm xmlns:a="http://schemas.openxmlformats.org/drawingml/2006/main">
-            <a:off x="6076950" y="1276350"/>
-            <a:ext cx="5505450" cy="4629150"/>
+            <a:off x="5907617" y="1600200"/>
+            <a:ext cx="5672667" cy="3190875"/>
           </a:xfrm>
           <a:prstGeom xmlns:a="http://schemas.openxmlformats.org/drawingml/2006/main" prst="rect">
             <a:avLst/>
           </a:prstGeom>
         </p:spPr>
       </p:pic>
+      <p:sp>
+        <p:nvSpPr>
+          <p:cNvPr id="5" name="">
+            <a:extLst xmlns:a="http://schemas.openxmlformats.org/drawingml/2006/main">
+              <a:ext uri="{FF2B5EF4-FFF2-40B4-BE49-F238E27FC236}">
+                <a16:creationId xmlns:a16="http://schemas.microsoft.com/office/drawing/2014/main" id="{B1940849-4C3B-4828-BA83-CA75ED966822}"/>
+              </a:ext>
+            </a:extLst>
+          </p:cNvPr>
+          <p:cNvSpPr>
+            <a:spLocks xmlns:a="http://schemas.openxmlformats.org/drawingml/2006/main" noGrp="1"/>
+          </p:cNvSpPr>
+          <p:nvPr/>
+        </p:nvSpPr>
+        <p:spPr>
+          <a:xfrm xmlns:a="http://schemas.openxmlformats.org/drawingml/2006/main">
+            <a:off x="5905500" y="5048250"/>
+            <a:ext cx="5676900" cy="323850"/>
+          </a:xfrm>
+          <a:prstGeom xmlns:a="http://schemas.openxmlformats.org/drawingml/2006/main" prst="rect">
+            <a:avLst/>
+          </a:prstGeom>
+          <a:noFill xmlns:a="http://schemas.openxmlformats.org/drawingml/2006/main"/>
+          <a:ln xmlns:a="http://schemas.openxmlformats.org/drawingml/2006/main" w="0">
+            <a:noFill/>
+          </a:ln>
+        </p:spPr>
+        <p:txBody>
+          <a:bodyPr xmlns:a="http://schemas.openxmlformats.org/drawingml/2006/main" wrap="square" lIns="0" tIns="0" rIns="0" bIns="0" anchor="t">
+            <a:normAutofit fontScale="100000"/>
+          </a:bodyPr>
+          <a:lstStyle xmlns:a="http://schemas.openxmlformats.org/drawingml/2006/main"/>
+          <a:p xmlns:a="http://schemas.openxmlformats.org/drawingml/2006/main">
+            <a:pPr algn="ctr">
+              <a:lnSpc>
+                <a:spcPct val="100000"/>
+              </a:lnSpc>
+              <a:buNone/>
+              <a:defRPr sz="1575" b="1">
+                <a:solidFill>
+                  <a:srgbClr val="101114"/>
+                </a:solidFill>
+                <a:latin typeface="Helvetica Neue"/>
+                <a:ea typeface="Helvetica Neue"/>
+                <a:cs typeface="Helvetica Neue"/>
+              </a:defRPr>
+            </a:pPr>
+            <a:r>
+              <a:rPr sz="1575" b="1">
+                <a:solidFill>
+                  <a:srgbClr val="101114"/>
+                </a:solidFill>
+                <a:latin typeface="Helvetica Neue"/>
+                <a:ea typeface="Helvetica Neue"/>
+                <a:cs typeface="Helvetica Neue"/>
+              </a:rPr>
+              <a:t>NVIDIA DGX Spark</a:t>
+            </a:r>
+          </a:p>
+        </p:txBody>
+      </p:sp>
+      <p:sp>
+        <p:nvSpPr>
+          <p:cNvPr id="6" name="">
+            <a:extLst xmlns:a="http://schemas.openxmlformats.org/drawingml/2006/main">
+              <a:ext uri="{FF2B5EF4-FFF2-40B4-BE49-F238E27FC236}">
+                <a16:creationId xmlns:a16="http://schemas.microsoft.com/office/drawing/2014/main" id="{41AEBE2D-1EA9-49A7-BD43-30A6C78EC9CE}"/>
+              </a:ext>
+            </a:extLst>
+          </p:cNvPr>
+          <p:cNvSpPr>
+            <a:spLocks xmlns:a="http://schemas.openxmlformats.org/drawingml/2006/main" noGrp="1"/>
+          </p:cNvSpPr>
+          <p:nvPr/>
+        </p:nvSpPr>
+        <p:spPr>
+          <a:xfrm xmlns:a="http://schemas.openxmlformats.org/drawingml/2006/main">
+            <a:off x="5905500" y="5400675"/>
+            <a:ext cx="5676900" cy="285750"/>
+          </a:xfrm>
+          <a:prstGeom xmlns:a="http://schemas.openxmlformats.org/drawingml/2006/main" prst="rect">
+            <a:avLst/>
+          </a:prstGeom>
+          <a:noFill xmlns:a="http://schemas.openxmlformats.org/drawingml/2006/main"/>
+          <a:ln xmlns:a="http://schemas.openxmlformats.org/drawingml/2006/main" w="0">
+            <a:noFill/>
+          </a:ln>
+        </p:spPr>
+        <p:txBody>
+          <a:bodyPr xmlns:a="http://schemas.openxmlformats.org/drawingml/2006/main" wrap="square" lIns="0" tIns="0" rIns="0" bIns="0" anchor="t">
+            <a:normAutofit fontScale="100000"/>
+          </a:bodyPr>
+          <a:lstStyle xmlns:a="http://schemas.openxmlformats.org/drawingml/2006/main"/>
+          <a:p xmlns:a="http://schemas.openxmlformats.org/drawingml/2006/main">
+            <a:pPr algn="ctr">
+              <a:lnSpc>
+                <a:spcPct val="100000"/>
+              </a:lnSpc>
+              <a:buNone/>
+              <a:defRPr sz="1200" b="0">
+                <a:solidFill>
+                  <a:srgbClr val="74716C"/>
+                </a:solidFill>
+                <a:latin typeface="Helvetica Neue"/>
+                <a:ea typeface="Helvetica Neue"/>
+                <a:cs typeface="Helvetica Neue"/>
+              </a:defRPr>
+            </a:pPr>
+            <a:r>
+              <a:rPr sz="1200" b="0">
+                <a:solidFill>
+                  <a:srgbClr val="74716C"/>
+                </a:solidFill>
+                <a:latin typeface="Helvetica Neue"/>
+                <a:ea typeface="Helvetica Neue"/>
+                <a:cs typeface="Helvetica Neue"/>
+              </a:rPr>
+              <a:t>A personal computer built for local AI</a:t>
+            </a:r>
+          </a:p>
+        </p:txBody>
+      </p:sp>
     </p:spTree>
     <p:extLst>
       <p:ext uri="{BB962C8B-B14F-4D97-AF65-F5344CB8AC3E}">
-        <p14:creationId xmlns:p14="http://schemas.microsoft.com/office/powerpoint/2010/main" val="620568188"/>
+        <p14:creationId xmlns:p14="http://schemas.microsoft.com/office/powerpoint/2010/main" val="84052885"/>
       </p:ext>
     </p:extLst>
   </p:cSld>
@@ -5163,7 +5273,7 @@
           <p:cNvPr id="10" name="">
             <a:extLst xmlns:a="http://schemas.openxmlformats.org/drawingml/2006/main">
               <a:ext uri="{FF2B5EF4-FFF2-40B4-BE49-F238E27FC236}">
-                <a16:creationId xmlns:a16="http://schemas.microsoft.com/office/drawing/2014/main" id="{C97C9EB1-CBEA-4CD1-BD5D-140B52F3A44D}"/>
+                <a16:creationId xmlns:a16="http://schemas.microsoft.com/office/drawing/2014/main" id="{42A9B008-C21C-42E8-A15D-36C13E8A6E5D}"/>
               </a:ext>
             </a:extLst>
           </p:cNvPr>
@@ -5224,7 +5334,7 @@
           <p:cNvPr id="2" name="">
             <a:extLst xmlns:a="http://schemas.openxmlformats.org/drawingml/2006/main">
               <a:ext uri="{FF2B5EF4-FFF2-40B4-BE49-F238E27FC236}">
-                <a16:creationId xmlns:a16="http://schemas.microsoft.com/office/drawing/2014/main" id="{70DBC5F6-0DC5-4366-AD79-6C8FF58498A7}"/>
+                <a16:creationId xmlns:a16="http://schemas.microsoft.com/office/drawing/2014/main" id="{4B905A82-395B-4D0F-B4A1-8ACAEC358867}"/>
               </a:ext>
             </a:extLst>
           </p:cNvPr>
@@ -5289,7 +5399,7 @@
           <p:nvPr/>
         </p:nvPicPr>
         <p:blipFill>
-          <a:blip xmlns:r="http://schemas.openxmlformats.org/officeDocument/2006/relationships" xmlns:a="http://schemas.openxmlformats.org/drawingml/2006/main" r:embed="R475912e981624d15"/>
+          <a:blip xmlns:r="http://schemas.openxmlformats.org/officeDocument/2006/relationships" xmlns:a="http://schemas.openxmlformats.org/drawingml/2006/main" r:embed="R3b516822882f4bc6"/>
           <a:stretch xmlns:a="http://schemas.openxmlformats.org/drawingml/2006/main"/>
         </p:blipFill>
         <p:spPr>
@@ -5311,7 +5421,7 @@
           <p:nvPr/>
         </p:nvPicPr>
         <p:blipFill>
-          <a:blip xmlns:r="http://schemas.openxmlformats.org/officeDocument/2006/relationships" xmlns:a="http://schemas.openxmlformats.org/drawingml/2006/main" r:embed="R35987966a6924935"/>
+          <a:blip xmlns:r="http://schemas.openxmlformats.org/officeDocument/2006/relationships" xmlns:a="http://schemas.openxmlformats.org/drawingml/2006/main" r:embed="Re043f6751d694ad0"/>
           <a:stretch xmlns:a="http://schemas.openxmlformats.org/drawingml/2006/main"/>
         </p:blipFill>
         <p:spPr>
@@ -5333,7 +5443,7 @@
           <p:nvPr/>
         </p:nvPicPr>
         <p:blipFill>
-          <a:blip xmlns:r="http://schemas.openxmlformats.org/officeDocument/2006/relationships" xmlns:a="http://schemas.openxmlformats.org/drawingml/2006/main" r:embed="R7aacd8cfac804daa"/>
+          <a:blip xmlns:r="http://schemas.openxmlformats.org/officeDocument/2006/relationships" xmlns:a="http://schemas.openxmlformats.org/drawingml/2006/main" r:embed="R31feb34ff7164a26"/>
           <a:stretch xmlns:a="http://schemas.openxmlformats.org/drawingml/2006/main"/>
         </p:blipFill>
         <p:spPr>
@@ -5351,7 +5461,7 @@
           <p:cNvPr id="6" name="">
             <a:extLst xmlns:a="http://schemas.openxmlformats.org/drawingml/2006/main">
               <a:ext uri="{FF2B5EF4-FFF2-40B4-BE49-F238E27FC236}">
-                <a16:creationId xmlns:a16="http://schemas.microsoft.com/office/drawing/2014/main" id="{BA3890F2-56E3-4AEE-96F2-1140E7448D0C}"/>
+                <a16:creationId xmlns:a16="http://schemas.microsoft.com/office/drawing/2014/main" id="{93D6CB6A-A24E-4126-A46D-33ECFF0B006E}"/>
               </a:ext>
             </a:extLst>
           </p:cNvPr>
@@ -5412,7 +5522,7 @@
           <p:cNvPr id="7" name="">
             <a:extLst xmlns:a="http://schemas.openxmlformats.org/drawingml/2006/main">
               <a:ext uri="{FF2B5EF4-FFF2-40B4-BE49-F238E27FC236}">
-                <a16:creationId xmlns:a16="http://schemas.microsoft.com/office/drawing/2014/main" id="{6094FD78-C204-4C17-9BFB-EBF9B7D7F464}"/>
+                <a16:creationId xmlns:a16="http://schemas.microsoft.com/office/drawing/2014/main" id="{B69C8D19-EA5C-49EF-9BF1-19F5011402DE}"/>
               </a:ext>
             </a:extLst>
           </p:cNvPr>
@@ -5473,7 +5583,7 @@
           <p:cNvPr id="8" name="">
             <a:extLst xmlns:a="http://schemas.openxmlformats.org/drawingml/2006/main">
               <a:ext uri="{FF2B5EF4-FFF2-40B4-BE49-F238E27FC236}">
-                <a16:creationId xmlns:a16="http://schemas.microsoft.com/office/drawing/2014/main" id="{3808AF66-1632-4142-BADD-5B3B44EB2F7F}"/>
+                <a16:creationId xmlns:a16="http://schemas.microsoft.com/office/drawing/2014/main" id="{C08B548F-FAB5-4007-9930-EEE24332C29E}"/>
               </a:ext>
             </a:extLst>
           </p:cNvPr>
@@ -5534,7 +5644,7 @@
           <p:cNvPr id="9" name="">
             <a:extLst xmlns:a="http://schemas.openxmlformats.org/drawingml/2006/main">
               <a:ext uri="{FF2B5EF4-FFF2-40B4-BE49-F238E27FC236}">
-                <a16:creationId xmlns:a16="http://schemas.microsoft.com/office/drawing/2014/main" id="{8C9B0243-D79D-484D-B50C-EF1F4C1FAFA1}"/>
+                <a16:creationId xmlns:a16="http://schemas.microsoft.com/office/drawing/2014/main" id="{851CC703-D5CB-4F65-AC4A-06D16CA7A3DC}"/>
               </a:ext>
             </a:extLst>
           </p:cNvPr>
@@ -5593,7 +5703,7 @@
     </p:spTree>
     <p:extLst>
       <p:ext uri="{BB962C8B-B14F-4D97-AF65-F5344CB8AC3E}">
-        <p14:creationId xmlns:p14="http://schemas.microsoft.com/office/powerpoint/2010/main" val="263137619"/>
+        <p14:creationId xmlns:p14="http://schemas.microsoft.com/office/powerpoint/2010/main" val="1215291210"/>
       </p:ext>
     </p:extLst>
   </p:cSld>
@@ -5624,7 +5734,7 @@
           <p:cNvPr id="6" name="">
             <a:extLst xmlns:a="http://schemas.openxmlformats.org/drawingml/2006/main">
               <a:ext uri="{FF2B5EF4-FFF2-40B4-BE49-F238E27FC236}">
-                <a16:creationId xmlns:a16="http://schemas.microsoft.com/office/drawing/2014/main" id="{78308CDF-E914-4338-A61F-E629AEB539BD}"/>
+                <a16:creationId xmlns:a16="http://schemas.microsoft.com/office/drawing/2014/main" id="{D1E82359-3052-417A-89FA-42BB4B08CD42}"/>
               </a:ext>
             </a:extLst>
           </p:cNvPr>
@@ -5685,7 +5795,7 @@
           <p:cNvPr id="2" name="">
             <a:extLst xmlns:a="http://schemas.openxmlformats.org/drawingml/2006/main">
               <a:ext uri="{FF2B5EF4-FFF2-40B4-BE49-F238E27FC236}">
-                <a16:creationId xmlns:a16="http://schemas.microsoft.com/office/drawing/2014/main" id="{F35F19E8-4C30-4D7D-8622-011BEB25837B}"/>
+                <a16:creationId xmlns:a16="http://schemas.microsoft.com/office/drawing/2014/main" id="{EFDA4337-6FC8-4DF4-B3F9-2D4A6B143D8C}"/>
               </a:ext>
             </a:extLst>
           </p:cNvPr>
@@ -5746,7 +5856,7 @@
           <p:cNvPr id="3" name="">
             <a:extLst xmlns:a="http://schemas.openxmlformats.org/drawingml/2006/main">
               <a:ext uri="{FF2B5EF4-FFF2-40B4-BE49-F238E27FC236}">
-                <a16:creationId xmlns:a16="http://schemas.microsoft.com/office/drawing/2014/main" id="{022A7A72-545E-4A03-AAF1-0A9DA10897A2}"/>
+                <a16:creationId xmlns:a16="http://schemas.microsoft.com/office/drawing/2014/main" id="{87696321-D688-4E4E-B61E-A8A066D9F207}"/>
               </a:ext>
             </a:extLst>
           </p:cNvPr>
@@ -5807,7 +5917,7 @@
           <p:cNvPr id="4" name="">
             <a:extLst xmlns:a="http://schemas.openxmlformats.org/drawingml/2006/main">
               <a:ext uri="{FF2B5EF4-FFF2-40B4-BE49-F238E27FC236}">
-                <a16:creationId xmlns:a16="http://schemas.microsoft.com/office/drawing/2014/main" id="{21248981-54B2-4CF5-B0F5-BB068ACD67B9}"/>
+                <a16:creationId xmlns:a16="http://schemas.microsoft.com/office/drawing/2014/main" id="{9CC4C7F0-2CA1-4171-A271-7726E436757B}"/>
               </a:ext>
             </a:extLst>
           </p:cNvPr>
@@ -5895,7 +6005,7 @@
           <p:cNvPr id="5" name="">
             <a:extLst xmlns:a="http://schemas.openxmlformats.org/drawingml/2006/main">
               <a:ext uri="{FF2B5EF4-FFF2-40B4-BE49-F238E27FC236}">
-                <a16:creationId xmlns:a16="http://schemas.microsoft.com/office/drawing/2014/main" id="{308C425C-8780-4B39-8482-912E79F23AA5}"/>
+                <a16:creationId xmlns:a16="http://schemas.microsoft.com/office/drawing/2014/main" id="{D932C19D-0D4B-4D1B-8994-8EEE24C64977}"/>
               </a:ext>
             </a:extLst>
           </p:cNvPr>
@@ -5954,7 +6064,7 @@
     </p:spTree>
     <p:extLst>
       <p:ext uri="{BB962C8B-B14F-4D97-AF65-F5344CB8AC3E}">
-        <p14:creationId xmlns:p14="http://schemas.microsoft.com/office/powerpoint/2010/main" val="1141374942"/>
+        <p14:creationId xmlns:p14="http://schemas.microsoft.com/office/powerpoint/2010/main" val="784642758"/>
       </p:ext>
     </p:extLst>
   </p:cSld>
@@ -5985,7 +6095,7 @@
           <p:cNvPr id="7" name="">
             <a:extLst xmlns:a="http://schemas.openxmlformats.org/drawingml/2006/main">
               <a:ext uri="{FF2B5EF4-FFF2-40B4-BE49-F238E27FC236}">
-                <a16:creationId xmlns:a16="http://schemas.microsoft.com/office/drawing/2014/main" id="{0241E290-D03D-4BF9-BFDB-36848CC7BCB9}"/>
+                <a16:creationId xmlns:a16="http://schemas.microsoft.com/office/drawing/2014/main" id="{4D03FC64-FDF0-4A83-B49C-A4B14A52949B}"/>
               </a:ext>
             </a:extLst>
           </p:cNvPr>
@@ -6046,7 +6156,7 @@
           <p:cNvPr id="2" name="">
             <a:extLst xmlns:a="http://schemas.openxmlformats.org/drawingml/2006/main">
               <a:ext uri="{FF2B5EF4-FFF2-40B4-BE49-F238E27FC236}">
-                <a16:creationId xmlns:a16="http://schemas.microsoft.com/office/drawing/2014/main" id="{204DA9BC-D6E6-4C2D-B86F-00D0A91F1B8B}"/>
+                <a16:creationId xmlns:a16="http://schemas.microsoft.com/office/drawing/2014/main" id="{4E7310F4-A553-4858-8344-202DCCA5AF54}"/>
               </a:ext>
             </a:extLst>
           </p:cNvPr>
@@ -6107,7 +6217,7 @@
           <p:cNvPr id="3" name="">
             <a:extLst xmlns:a="http://schemas.openxmlformats.org/drawingml/2006/main">
               <a:ext uri="{FF2B5EF4-FFF2-40B4-BE49-F238E27FC236}">
-                <a16:creationId xmlns:a16="http://schemas.microsoft.com/office/drawing/2014/main" id="{9C937089-CD09-4489-A870-CCD2EF42DCC8}"/>
+                <a16:creationId xmlns:a16="http://schemas.microsoft.com/office/drawing/2014/main" id="{D3EA702D-2B0F-443A-BB84-27E656FA2C7B}"/>
               </a:ext>
             </a:extLst>
           </p:cNvPr>
@@ -6175,7 +6285,7 @@
         </p:xfrm>
         <a:graphic xmlns:a="http://schemas.openxmlformats.org/drawingml/2006/main">
           <a:graphicData uri="http://schemas.openxmlformats.org/drawingml/2006/chart">
-            <c:chart xmlns:r="http://schemas.openxmlformats.org/officeDocument/2006/relationships" xmlns:c="http://schemas.openxmlformats.org/drawingml/2006/chart" r:id="R7e84164ba3694493"/>
+            <c:chart xmlns:r="http://schemas.openxmlformats.org/officeDocument/2006/relationships" xmlns:c="http://schemas.openxmlformats.org/drawingml/2006/chart" r:id="R1ffbef7433f74d87"/>
           </a:graphicData>
         </a:graphic>
       </p:graphicFrame>
@@ -6184,7 +6294,7 @@
           <p:cNvPr id="5" name="">
             <a:extLst xmlns:a="http://schemas.openxmlformats.org/drawingml/2006/main">
               <a:ext uri="{FF2B5EF4-FFF2-40B4-BE49-F238E27FC236}">
-                <a16:creationId xmlns:a16="http://schemas.microsoft.com/office/drawing/2014/main" id="{CB6ECF01-5FAD-477B-B228-5E36D53FDE0D}"/>
+                <a16:creationId xmlns:a16="http://schemas.microsoft.com/office/drawing/2014/main" id="{D674DCBD-9D0E-4CE3-B4F6-F3F9F066AA84}"/>
               </a:ext>
             </a:extLst>
           </p:cNvPr>
@@ -6272,7 +6382,7 @@
           <p:cNvPr id="6" name="">
             <a:extLst xmlns:a="http://schemas.openxmlformats.org/drawingml/2006/main">
               <a:ext uri="{FF2B5EF4-FFF2-40B4-BE49-F238E27FC236}">
-                <a16:creationId xmlns:a16="http://schemas.microsoft.com/office/drawing/2014/main" id="{05DD8332-6412-49E6-A3C6-0D92F618E80E}"/>
+                <a16:creationId xmlns:a16="http://schemas.microsoft.com/office/drawing/2014/main" id="{844712B8-02A7-4E32-BCBE-3994DBB5732E}"/>
               </a:ext>
             </a:extLst>
           </p:cNvPr>
@@ -6331,7 +6441,7 @@
     </p:spTree>
     <p:extLst>
       <p:ext uri="{BB962C8B-B14F-4D97-AF65-F5344CB8AC3E}">
-        <p14:creationId xmlns:p14="http://schemas.microsoft.com/office/powerpoint/2010/main" val="362319804"/>
+        <p14:creationId xmlns:p14="http://schemas.microsoft.com/office/powerpoint/2010/main" val="886034084"/>
       </p:ext>
     </p:extLst>
   </p:cSld>
@@ -6362,7 +6472,7 @@
           <p:cNvPr id="5" name="">
             <a:extLst xmlns:a="http://schemas.openxmlformats.org/drawingml/2006/main">
               <a:ext uri="{FF2B5EF4-FFF2-40B4-BE49-F238E27FC236}">
-                <a16:creationId xmlns:a16="http://schemas.microsoft.com/office/drawing/2014/main" id="{C000809A-9912-4DE4-84CC-3EAE87130549}"/>
+                <a16:creationId xmlns:a16="http://schemas.microsoft.com/office/drawing/2014/main" id="{0371FD06-5F76-4586-8EE7-92D29665068D}"/>
               </a:ext>
             </a:extLst>
           </p:cNvPr>
@@ -6423,7 +6533,7 @@
           <p:cNvPr id="2" name="">
             <a:extLst xmlns:a="http://schemas.openxmlformats.org/drawingml/2006/main">
               <a:ext uri="{FF2B5EF4-FFF2-40B4-BE49-F238E27FC236}">
-                <a16:creationId xmlns:a16="http://schemas.microsoft.com/office/drawing/2014/main" id="{BE0166E1-9AE1-402B-9357-1D94E7B89D8D}"/>
+                <a16:creationId xmlns:a16="http://schemas.microsoft.com/office/drawing/2014/main" id="{04555F19-F863-40AB-B552-D47DC3FA7309}"/>
               </a:ext>
             </a:extLst>
           </p:cNvPr>
@@ -6484,7 +6594,7 @@
           <p:cNvPr id="3" name="">
             <a:extLst xmlns:a="http://schemas.openxmlformats.org/drawingml/2006/main">
               <a:ext uri="{FF2B5EF4-FFF2-40B4-BE49-F238E27FC236}">
-                <a16:creationId xmlns:a16="http://schemas.microsoft.com/office/drawing/2014/main" id="{56839FE0-C3C9-4EDC-8B1B-C03FC81A4657}"/>
+                <a16:creationId xmlns:a16="http://schemas.microsoft.com/office/drawing/2014/main" id="{918620BC-8EA1-4ED4-86C7-58F31E8514F4}"/>
               </a:ext>
             </a:extLst>
           </p:cNvPr>
@@ -6572,7 +6682,7 @@
           <p:cNvPr id="4" name="">
             <a:extLst xmlns:a="http://schemas.openxmlformats.org/drawingml/2006/main">
               <a:ext uri="{FF2B5EF4-FFF2-40B4-BE49-F238E27FC236}">
-                <a16:creationId xmlns:a16="http://schemas.microsoft.com/office/drawing/2014/main" id="{1748502B-FF29-491C-9BFB-D60A10BB05B7}"/>
+                <a16:creationId xmlns:a16="http://schemas.microsoft.com/office/drawing/2014/main" id="{27D193F2-2D0D-41C4-8E92-9B047DE8549B}"/>
               </a:ext>
             </a:extLst>
           </p:cNvPr>
@@ -6601,7 +6711,7 @@
     </p:spTree>
     <p:extLst>
       <p:ext uri="{BB962C8B-B14F-4D97-AF65-F5344CB8AC3E}">
-        <p14:creationId xmlns:p14="http://schemas.microsoft.com/office/powerpoint/2010/main" val="688308976"/>
+        <p14:creationId xmlns:p14="http://schemas.microsoft.com/office/powerpoint/2010/main" val="1107780271"/>
       </p:ext>
     </p:extLst>
   </p:cSld>
@@ -6632,7 +6742,7 @@
           <p:cNvPr id="9" name="">
             <a:extLst xmlns:a="http://schemas.openxmlformats.org/drawingml/2006/main">
               <a:ext uri="{FF2B5EF4-FFF2-40B4-BE49-F238E27FC236}">
-                <a16:creationId xmlns:a16="http://schemas.microsoft.com/office/drawing/2014/main" id="{F5F4255E-5172-4608-8DF9-C832C39F1A37}"/>
+                <a16:creationId xmlns:a16="http://schemas.microsoft.com/office/drawing/2014/main" id="{FFE06046-7B77-4ACA-AB8E-5A8F7295EE96}"/>
               </a:ext>
             </a:extLst>
           </p:cNvPr>
@@ -6693,7 +6803,7 @@
           <p:cNvPr id="2" name="">
             <a:extLst xmlns:a="http://schemas.openxmlformats.org/drawingml/2006/main">
               <a:ext uri="{FF2B5EF4-FFF2-40B4-BE49-F238E27FC236}">
-                <a16:creationId xmlns:a16="http://schemas.microsoft.com/office/drawing/2014/main" id="{D81ECBE1-3E4E-49C0-9C33-436EEA3656D3}"/>
+                <a16:creationId xmlns:a16="http://schemas.microsoft.com/office/drawing/2014/main" id="{274FF35C-D531-48ED-A9B1-F148549DFB03}"/>
               </a:ext>
             </a:extLst>
           </p:cNvPr>
@@ -6754,7 +6864,7 @@
           <p:cNvPr id="3" name="">
             <a:extLst xmlns:a="http://schemas.openxmlformats.org/drawingml/2006/main">
               <a:ext uri="{FF2B5EF4-FFF2-40B4-BE49-F238E27FC236}">
-                <a16:creationId xmlns:a16="http://schemas.microsoft.com/office/drawing/2014/main" id="{4C61CB51-085B-41A7-AD27-130FDDED5BE5}"/>
+                <a16:creationId xmlns:a16="http://schemas.microsoft.com/office/drawing/2014/main" id="{0BB042AF-B670-446D-95A4-8BA9C447978C}"/>
               </a:ext>
             </a:extLst>
           </p:cNvPr>
@@ -6815,7 +6925,7 @@
           <p:cNvPr id="4" name="">
             <a:extLst xmlns:a="http://schemas.openxmlformats.org/drawingml/2006/main">
               <a:ext uri="{FF2B5EF4-FFF2-40B4-BE49-F238E27FC236}">
-                <a16:creationId xmlns:a16="http://schemas.microsoft.com/office/drawing/2014/main" id="{394DF385-E8D1-49B5-930E-435D0503E17B}"/>
+                <a16:creationId xmlns:a16="http://schemas.microsoft.com/office/drawing/2014/main" id="{D7B0F2CE-BE69-4081-A026-C5457E0B1E5E}"/>
               </a:ext>
             </a:extLst>
           </p:cNvPr>
@@ -6876,7 +6986,7 @@
           <p:cNvPr id="5" name="">
             <a:extLst xmlns:a="http://schemas.openxmlformats.org/drawingml/2006/main">
               <a:ext uri="{FF2B5EF4-FFF2-40B4-BE49-F238E27FC236}">
-                <a16:creationId xmlns:a16="http://schemas.microsoft.com/office/drawing/2014/main" id="{4B404A33-FBE9-4DD4-B80C-B3B7CBC88E7C}"/>
+                <a16:creationId xmlns:a16="http://schemas.microsoft.com/office/drawing/2014/main" id="{312D97D2-1932-4C7D-AB7E-47748F2D326F}"/>
               </a:ext>
             </a:extLst>
           </p:cNvPr>
@@ -6907,7 +7017,7 @@
           <p:cNvPr id="6" name="">
             <a:extLst xmlns:a="http://schemas.openxmlformats.org/drawingml/2006/main">
               <a:ext uri="{FF2B5EF4-FFF2-40B4-BE49-F238E27FC236}">
-                <a16:creationId xmlns:a16="http://schemas.microsoft.com/office/drawing/2014/main" id="{F1420B3F-2DFF-4364-A35A-56586F68CF34}"/>
+                <a16:creationId xmlns:a16="http://schemas.microsoft.com/office/drawing/2014/main" id="{188EBB60-C32E-4F94-B65C-36BA9EC2B405}"/>
               </a:ext>
             </a:extLst>
           </p:cNvPr>
@@ -6968,7 +7078,7 @@
           <p:cNvPr id="7" name="">
             <a:extLst xmlns:a="http://schemas.openxmlformats.org/drawingml/2006/main">
               <a:ext uri="{FF2B5EF4-FFF2-40B4-BE49-F238E27FC236}">
-                <a16:creationId xmlns:a16="http://schemas.microsoft.com/office/drawing/2014/main" id="{AAFBDFEB-BEDA-4B13-9399-806AF09642A6}"/>
+                <a16:creationId xmlns:a16="http://schemas.microsoft.com/office/drawing/2014/main" id="{92635ED9-1084-48AA-B21D-479511AB9230}"/>
               </a:ext>
             </a:extLst>
           </p:cNvPr>
@@ -7029,7 +7139,7 @@
           <p:cNvPr id="8" name="">
             <a:extLst xmlns:a="http://schemas.openxmlformats.org/drawingml/2006/main">
               <a:ext uri="{FF2B5EF4-FFF2-40B4-BE49-F238E27FC236}">
-                <a16:creationId xmlns:a16="http://schemas.microsoft.com/office/drawing/2014/main" id="{613BEF56-E687-4EB6-BA69-76B7F7985A66}"/>
+                <a16:creationId xmlns:a16="http://schemas.microsoft.com/office/drawing/2014/main" id="{A3DB2EAF-423E-4F96-8D82-F86B34BE6242}"/>
               </a:ext>
             </a:extLst>
           </p:cNvPr>
@@ -7088,7 +7198,7 @@
     </p:spTree>
     <p:extLst>
       <p:ext uri="{BB962C8B-B14F-4D97-AF65-F5344CB8AC3E}">
-        <p14:creationId xmlns:p14="http://schemas.microsoft.com/office/powerpoint/2010/main" val="1182568437"/>
+        <p14:creationId xmlns:p14="http://schemas.microsoft.com/office/powerpoint/2010/main" val="944119964"/>
       </p:ext>
     </p:extLst>
   </p:cSld>

</xml_diff>

<commit_message>
Redesign local AI cost slide
</commit_message>
<xml_diff>
--- a/outputs/presentations/Will AI Be Completely Free - Final.pptx
+++ b/outputs/presentations/Will AI Be Completely Free - Final.pptx
@@ -2,25 +2,25 @@
 <file path=ppt/presentation.xml><?xml version="1.0" encoding="utf-8"?>
 <p:presentation xmlns:p="http://schemas.openxmlformats.org/presentationml/2006/main">
   <p:sldMasterIdLst>
-    <p:sldMasterId xmlns:r="http://schemas.openxmlformats.org/officeDocument/2006/relationships" id="2147483648" r:id="Rf06c90b66dc14c4f"/>
+    <p:sldMasterId xmlns:r="http://schemas.openxmlformats.org/officeDocument/2006/relationships" id="2147483648" r:id="Rb24cd55203ff4bec"/>
   </p:sldMasterIdLst>
   <p:notesMasterIdLst>
-    <p:notesMasterId xmlns:r="http://schemas.openxmlformats.org/officeDocument/2006/relationships" r:id="Ra9a1997eb1974c78"/>
+    <p:notesMasterId xmlns:r="http://schemas.openxmlformats.org/officeDocument/2006/relationships" r:id="Rf4a3788d7e5c489a"/>
   </p:notesMasterIdLst>
   <p:sldIdLst>
-    <p:sldId xmlns:r="http://schemas.openxmlformats.org/officeDocument/2006/relationships" id="256" r:id="R08c1cbf6d6634f1f"/>
-    <p:sldId xmlns:r="http://schemas.openxmlformats.org/officeDocument/2006/relationships" id="257" r:id="R3f845a17d54843cc"/>
-    <p:sldId xmlns:r="http://schemas.openxmlformats.org/officeDocument/2006/relationships" id="258" r:id="R7eb2f739e432445a"/>
-    <p:sldId xmlns:r="http://schemas.openxmlformats.org/officeDocument/2006/relationships" id="259" r:id="Radba26d5f8e14500"/>
-    <p:sldId xmlns:r="http://schemas.openxmlformats.org/officeDocument/2006/relationships" id="260" r:id="Re6f4c8e6671246e8"/>
-    <p:sldId xmlns:r="http://schemas.openxmlformats.org/officeDocument/2006/relationships" id="261" r:id="R012e7cfd203a4c35"/>
-    <p:sldId xmlns:r="http://schemas.openxmlformats.org/officeDocument/2006/relationships" id="262" r:id="Rcba38dce71f44493"/>
-    <p:sldId xmlns:r="http://schemas.openxmlformats.org/officeDocument/2006/relationships" id="263" r:id="R3c679a70da8d4561"/>
-    <p:sldId xmlns:r="http://schemas.openxmlformats.org/officeDocument/2006/relationships" id="264" r:id="R47fedda725344b3e"/>
-    <p:sldId xmlns:r="http://schemas.openxmlformats.org/officeDocument/2006/relationships" id="265" r:id="Re894ed0c9f97434b"/>
-    <p:sldId xmlns:r="http://schemas.openxmlformats.org/officeDocument/2006/relationships" id="266" r:id="R8fe42322a62b45f0"/>
-    <p:sldId xmlns:r="http://schemas.openxmlformats.org/officeDocument/2006/relationships" id="267" r:id="Rcd1821cfbe4847ed"/>
-    <p:sldId xmlns:r="http://schemas.openxmlformats.org/officeDocument/2006/relationships" id="268" r:id="R565ffc51684f4117"/>
+    <p:sldId xmlns:r="http://schemas.openxmlformats.org/officeDocument/2006/relationships" id="256" r:id="R388a8b4c3f4349a7"/>
+    <p:sldId xmlns:r="http://schemas.openxmlformats.org/officeDocument/2006/relationships" id="257" r:id="Rcc49f4046a2641a3"/>
+    <p:sldId xmlns:r="http://schemas.openxmlformats.org/officeDocument/2006/relationships" id="258" r:id="R242dcebfb99e4aec"/>
+    <p:sldId xmlns:r="http://schemas.openxmlformats.org/officeDocument/2006/relationships" id="259" r:id="R134bcc4eedfa478f"/>
+    <p:sldId xmlns:r="http://schemas.openxmlformats.org/officeDocument/2006/relationships" id="260" r:id="R6f4f3bc00c8e464b"/>
+    <p:sldId xmlns:r="http://schemas.openxmlformats.org/officeDocument/2006/relationships" id="261" r:id="R787edf96089d48bc"/>
+    <p:sldId xmlns:r="http://schemas.openxmlformats.org/officeDocument/2006/relationships" id="262" r:id="R81bfe8c9d54f42cf"/>
+    <p:sldId xmlns:r="http://schemas.openxmlformats.org/officeDocument/2006/relationships" id="263" r:id="R57b6d7bcce56433f"/>
+    <p:sldId xmlns:r="http://schemas.openxmlformats.org/officeDocument/2006/relationships" id="264" r:id="R4f38e4a5da634cba"/>
+    <p:sldId xmlns:r="http://schemas.openxmlformats.org/officeDocument/2006/relationships" id="265" r:id="Re2faa50dbcaf4231"/>
+    <p:sldId xmlns:r="http://schemas.openxmlformats.org/officeDocument/2006/relationships" id="266" r:id="Ra36173b5faf64754"/>
+    <p:sldId xmlns:r="http://schemas.openxmlformats.org/officeDocument/2006/relationships" id="267" r:id="R72bec3aeb8dd4195"/>
+    <p:sldId xmlns:r="http://schemas.openxmlformats.org/officeDocument/2006/relationships" id="268" r:id="R9f07dac1cc584021"/>
   </p:sldIdLst>
   <p:sldSz cx="12192000" cy="6858000"/>
   <p:notesSz cx="6858000" cy="9144000"/>
@@ -1154,7 +1154,7 @@
           <a:lstStyle xmlns:a="http://schemas.openxmlformats.org/drawingml/2006/main"/>
           <a:p xmlns:a="http://schemas.openxmlformats.org/drawingml/2006/main">
             <a:r>
-              <a:t>Local AI feels more like software you own. It can keep private files on your machine and continue working when Wi-Fi drops. Once the computer is ready, repeated questions do not create a visible new charge. That matters most for ordinary work you do often, rather than the most difficult question imaginable.</a:t>
+              <a:t>Once the model is installed, your computer produces each new answer. The request does not create a separate cloud charge, so frequent use can start to feel free. But it is not really free. You still paid for the device, and the device still uses electricity. The next slide compares that upfront cost with cloud services, where the cost usually grows with use.</a:t>
             </a:r>
           </a:p>
         </p:txBody>
@@ -1432,7 +1432,7 @@
   </p:cSld>
   <p:clrMap bg1="lt1" tx1="dk1" bg2="lt2" tx2="dk2" accent1="accent1" accent2="accent2" accent3="accent3" accent4="accent4" accent5="accent5" accent6="accent6" hlink="hlink" folHlink="folHlink"/>
   <p:sldLayoutIdLst>
-    <p:sldLayoutId xmlns:r="http://schemas.openxmlformats.org/officeDocument/2006/relationships" id="2147483649" r:id="R76329de9bb444b25"/>
+    <p:sldLayoutId xmlns:r="http://schemas.openxmlformats.org/officeDocument/2006/relationships" id="2147483649" r:id="R912bd0333b1c447c"/>
   </p:sldLayoutIdLst>
   <p:txStyles>
     <p:titleStyle>
@@ -2262,7 +2262,7 @@
           <p:cNvPr id="5" name="">
             <a:extLst xmlns:a="http://schemas.openxmlformats.org/drawingml/2006/main">
               <a:ext uri="{FF2B5EF4-FFF2-40B4-BE49-F238E27FC236}">
-                <a16:creationId xmlns:a16="http://schemas.microsoft.com/office/drawing/2014/main" id="{682DDEEB-59AF-4891-881D-5B2ECC4C8501}"/>
+                <a16:creationId xmlns:a16="http://schemas.microsoft.com/office/drawing/2014/main" id="{84517631-3B1F-4361-90E0-AE8C0D74602D}"/>
               </a:ext>
             </a:extLst>
           </p:cNvPr>
@@ -2350,7 +2350,7 @@
           <p:cNvPr id="2" name="">
             <a:extLst xmlns:a="http://schemas.openxmlformats.org/drawingml/2006/main">
               <a:ext uri="{FF2B5EF4-FFF2-40B4-BE49-F238E27FC236}">
-                <a16:creationId xmlns:a16="http://schemas.microsoft.com/office/drawing/2014/main" id="{9F598CFF-17DF-4A28-9AF5-98E9B75CF6A8}"/>
+                <a16:creationId xmlns:a16="http://schemas.microsoft.com/office/drawing/2014/main" id="{351A8C4F-E8FF-417D-A86C-2C6EC9D0E31E}"/>
               </a:ext>
             </a:extLst>
           </p:cNvPr>
@@ -2411,7 +2411,7 @@
           <p:cNvPr id="3" name="">
             <a:extLst xmlns:a="http://schemas.openxmlformats.org/drawingml/2006/main">
               <a:ext uri="{FF2B5EF4-FFF2-40B4-BE49-F238E27FC236}">
-                <a16:creationId xmlns:a16="http://schemas.microsoft.com/office/drawing/2014/main" id="{34F99922-2759-48B3-9912-74B9E0B324F9}"/>
+                <a16:creationId xmlns:a16="http://schemas.microsoft.com/office/drawing/2014/main" id="{C10152B5-0E33-48C0-937B-CF3DB98DC705}"/>
               </a:ext>
             </a:extLst>
           </p:cNvPr>
@@ -2442,7 +2442,7 @@
           <p:cNvPr id="4" name="">
             <a:extLst xmlns:a="http://schemas.openxmlformats.org/drawingml/2006/main">
               <a:ext uri="{FF2B5EF4-FFF2-40B4-BE49-F238E27FC236}">
-                <a16:creationId xmlns:a16="http://schemas.microsoft.com/office/drawing/2014/main" id="{C2F89EEE-1BD3-44EF-9D60-FAA451D006E3}"/>
+                <a16:creationId xmlns:a16="http://schemas.microsoft.com/office/drawing/2014/main" id="{B4144EA7-CA56-47A2-8D88-2410D7644C48}"/>
               </a:ext>
             </a:extLst>
           </p:cNvPr>
@@ -2501,7 +2501,7 @@
     </p:spTree>
     <p:extLst>
       <p:ext uri="{BB962C8B-B14F-4D97-AF65-F5344CB8AC3E}">
-        <p14:creationId xmlns:p14="http://schemas.microsoft.com/office/powerpoint/2010/main" val="1539688086"/>
+        <p14:creationId xmlns:p14="http://schemas.microsoft.com/office/powerpoint/2010/main" val="1552867767"/>
       </p:ext>
     </p:extLst>
   </p:cSld>
@@ -2532,7 +2532,7 @@
           <p:cNvPr id="6" name="">
             <a:extLst xmlns:a="http://schemas.openxmlformats.org/drawingml/2006/main">
               <a:ext uri="{FF2B5EF4-FFF2-40B4-BE49-F238E27FC236}">
-                <a16:creationId xmlns:a16="http://schemas.microsoft.com/office/drawing/2014/main" id="{0C1562EB-753A-4E01-A5C8-59A53680FB87}"/>
+                <a16:creationId xmlns:a16="http://schemas.microsoft.com/office/drawing/2014/main" id="{BCA27C6C-60F6-4F9F-AEC2-2B9AB704BAC5}"/>
               </a:ext>
             </a:extLst>
           </p:cNvPr>
@@ -2593,7 +2593,7 @@
           <p:cNvPr id="2" name="">
             <a:extLst xmlns:a="http://schemas.openxmlformats.org/drawingml/2006/main">
               <a:ext uri="{FF2B5EF4-FFF2-40B4-BE49-F238E27FC236}">
-                <a16:creationId xmlns:a16="http://schemas.microsoft.com/office/drawing/2014/main" id="{34A52283-5132-40CD-9657-42643C27485C}"/>
+                <a16:creationId xmlns:a16="http://schemas.microsoft.com/office/drawing/2014/main" id="{EC93CEC5-0BF6-4508-A096-C64FD49BE4FB}"/>
               </a:ext>
             </a:extLst>
           </p:cNvPr>
@@ -2654,7 +2654,7 @@
           <p:cNvPr id="3" name="">
             <a:extLst xmlns:a="http://schemas.openxmlformats.org/drawingml/2006/main">
               <a:ext uri="{FF2B5EF4-FFF2-40B4-BE49-F238E27FC236}">
-                <a16:creationId xmlns:a16="http://schemas.microsoft.com/office/drawing/2014/main" id="{00736A8E-92BC-40B5-A0A5-B0CDCEC5FEA4}"/>
+                <a16:creationId xmlns:a16="http://schemas.microsoft.com/office/drawing/2014/main" id="{77A9911E-A2D2-415C-A59F-821669008B04}"/>
               </a:ext>
             </a:extLst>
           </p:cNvPr>
@@ -2715,7 +2715,7 @@
           <p:cNvPr id="4" name="">
             <a:extLst xmlns:a="http://schemas.openxmlformats.org/drawingml/2006/main">
               <a:ext uri="{FF2B5EF4-FFF2-40B4-BE49-F238E27FC236}">
-                <a16:creationId xmlns:a16="http://schemas.microsoft.com/office/drawing/2014/main" id="{8F9DFBAC-FC0A-4A7A-AE45-BDA7694791E3}"/>
+                <a16:creationId xmlns:a16="http://schemas.microsoft.com/office/drawing/2014/main" id="{0CA3A6F4-70F5-49C6-A660-FEA35735AD9D}"/>
               </a:ext>
             </a:extLst>
           </p:cNvPr>
@@ -2803,7 +2803,7 @@
           <p:cNvPr id="5" name="">
             <a:extLst xmlns:a="http://schemas.openxmlformats.org/drawingml/2006/main">
               <a:ext uri="{FF2B5EF4-FFF2-40B4-BE49-F238E27FC236}">
-                <a16:creationId xmlns:a16="http://schemas.microsoft.com/office/drawing/2014/main" id="{16FDBE7B-5C04-415F-ABC7-101E9A1DF4BB}"/>
+                <a16:creationId xmlns:a16="http://schemas.microsoft.com/office/drawing/2014/main" id="{A0AB0632-E75E-462F-8C7A-3B18740C8943}"/>
               </a:ext>
             </a:extLst>
           </p:cNvPr>
@@ -2862,7 +2862,7 @@
     </p:spTree>
     <p:extLst>
       <p:ext uri="{BB962C8B-B14F-4D97-AF65-F5344CB8AC3E}">
-        <p14:creationId xmlns:p14="http://schemas.microsoft.com/office/powerpoint/2010/main" val="338354140"/>
+        <p14:creationId xmlns:p14="http://schemas.microsoft.com/office/powerpoint/2010/main" val="1461373705"/>
       </p:ext>
     </p:extLst>
   </p:cSld>
@@ -2893,7 +2893,7 @@
           <p:cNvPr id="5" name="">
             <a:extLst xmlns:a="http://schemas.openxmlformats.org/drawingml/2006/main">
               <a:ext uri="{FF2B5EF4-FFF2-40B4-BE49-F238E27FC236}">
-                <a16:creationId xmlns:a16="http://schemas.microsoft.com/office/drawing/2014/main" id="{A8882EF7-BE56-4F97-B84B-B618EBF8C4F5}"/>
+                <a16:creationId xmlns:a16="http://schemas.microsoft.com/office/drawing/2014/main" id="{ED577BCF-406C-411A-98B6-8E9778DC1042}"/>
               </a:ext>
             </a:extLst>
           </p:cNvPr>
@@ -2954,7 +2954,7 @@
           <p:cNvPr id="2" name="">
             <a:extLst xmlns:a="http://schemas.openxmlformats.org/drawingml/2006/main">
               <a:ext uri="{FF2B5EF4-FFF2-40B4-BE49-F238E27FC236}">
-                <a16:creationId xmlns:a16="http://schemas.microsoft.com/office/drawing/2014/main" id="{DB23DF4F-F465-4911-B793-D97128310DAF}"/>
+                <a16:creationId xmlns:a16="http://schemas.microsoft.com/office/drawing/2014/main" id="{62FBD931-13D0-47F3-BDFF-245E15642997}"/>
               </a:ext>
             </a:extLst>
           </p:cNvPr>
@@ -3015,7 +3015,7 @@
           <p:cNvPr id="3" name="">
             <a:extLst xmlns:a="http://schemas.openxmlformats.org/drawingml/2006/main">
               <a:ext uri="{FF2B5EF4-FFF2-40B4-BE49-F238E27FC236}">
-                <a16:creationId xmlns:a16="http://schemas.microsoft.com/office/drawing/2014/main" id="{5F00A885-F58D-44D6-9249-E5EE7BE7B774}"/>
+                <a16:creationId xmlns:a16="http://schemas.microsoft.com/office/drawing/2014/main" id="{7A5943A8-0BDF-40FC-A18E-CC9FCE255120}"/>
               </a:ext>
             </a:extLst>
           </p:cNvPr>
@@ -3130,7 +3130,7 @@
           <p:cNvPr id="4" name="">
             <a:extLst xmlns:a="http://schemas.openxmlformats.org/drawingml/2006/main">
               <a:ext uri="{FF2B5EF4-FFF2-40B4-BE49-F238E27FC236}">
-                <a16:creationId xmlns:a16="http://schemas.microsoft.com/office/drawing/2014/main" id="{2B0C5093-9BD6-406B-A16F-211B4CEB7173}"/>
+                <a16:creationId xmlns:a16="http://schemas.microsoft.com/office/drawing/2014/main" id="{3C9946EE-DB02-43AC-B777-A06223040D8D}"/>
               </a:ext>
             </a:extLst>
           </p:cNvPr>
@@ -3189,7 +3189,7 @@
     </p:spTree>
     <p:extLst>
       <p:ext uri="{BB962C8B-B14F-4D97-AF65-F5344CB8AC3E}">
-        <p14:creationId xmlns:p14="http://schemas.microsoft.com/office/powerpoint/2010/main" val="792893701"/>
+        <p14:creationId xmlns:p14="http://schemas.microsoft.com/office/powerpoint/2010/main" val="283824812"/>
       </p:ext>
     </p:extLst>
   </p:cSld>
@@ -3220,7 +3220,7 @@
           <p:cNvPr id="9" name="">
             <a:extLst xmlns:a="http://schemas.openxmlformats.org/drawingml/2006/main">
               <a:ext uri="{FF2B5EF4-FFF2-40B4-BE49-F238E27FC236}">
-                <a16:creationId xmlns:a16="http://schemas.microsoft.com/office/drawing/2014/main" id="{EEC7CA3A-5196-4D73-ACFE-916AD7757D24}"/>
+                <a16:creationId xmlns:a16="http://schemas.microsoft.com/office/drawing/2014/main" id="{B1AE5AD2-96DB-4C5B-8B7E-0F447A17B5E8}"/>
               </a:ext>
             </a:extLst>
           </p:cNvPr>
@@ -3281,7 +3281,7 @@
           <p:cNvPr id="2" name="">
             <a:extLst xmlns:a="http://schemas.openxmlformats.org/drawingml/2006/main">
               <a:ext uri="{FF2B5EF4-FFF2-40B4-BE49-F238E27FC236}">
-                <a16:creationId xmlns:a16="http://schemas.microsoft.com/office/drawing/2014/main" id="{311C2376-5A6B-4157-9CB8-97BB648B0784}"/>
+                <a16:creationId xmlns:a16="http://schemas.microsoft.com/office/drawing/2014/main" id="{3EAD9E30-D001-4274-8B4D-066369C4658D}"/>
               </a:ext>
             </a:extLst>
           </p:cNvPr>
@@ -3342,7 +3342,7 @@
           <p:cNvPr id="3" name="">
             <a:extLst xmlns:a="http://schemas.openxmlformats.org/drawingml/2006/main">
               <a:ext uri="{FF2B5EF4-FFF2-40B4-BE49-F238E27FC236}">
-                <a16:creationId xmlns:a16="http://schemas.microsoft.com/office/drawing/2014/main" id="{9061841B-89B2-4278-92EE-F836441D9873}"/>
+                <a16:creationId xmlns:a16="http://schemas.microsoft.com/office/drawing/2014/main" id="{B8CD7ED3-2FB5-42B3-86C1-5BB7E8D1AEDA}"/>
               </a:ext>
             </a:extLst>
           </p:cNvPr>
@@ -3403,7 +3403,7 @@
           <p:cNvPr id="4" name="">
             <a:extLst xmlns:a="http://schemas.openxmlformats.org/drawingml/2006/main">
               <a:ext uri="{FF2B5EF4-FFF2-40B4-BE49-F238E27FC236}">
-                <a16:creationId xmlns:a16="http://schemas.microsoft.com/office/drawing/2014/main" id="{3DAC5DE2-E48A-4226-9DE3-DF897A3D85AB}"/>
+                <a16:creationId xmlns:a16="http://schemas.microsoft.com/office/drawing/2014/main" id="{5A1FF254-A3F2-48FB-BDC7-EA49FFC79751}"/>
               </a:ext>
             </a:extLst>
           </p:cNvPr>
@@ -3434,7 +3434,7 @@
           <p:cNvPr id="5" name="">
             <a:extLst xmlns:a="http://schemas.openxmlformats.org/drawingml/2006/main">
               <a:ext uri="{FF2B5EF4-FFF2-40B4-BE49-F238E27FC236}">
-                <a16:creationId xmlns:a16="http://schemas.microsoft.com/office/drawing/2014/main" id="{87ADE52C-442C-440F-B2CC-339031F4D561}"/>
+                <a16:creationId xmlns:a16="http://schemas.microsoft.com/office/drawing/2014/main" id="{0308ECED-B071-4C2A-911D-F9F43FBB53D9}"/>
               </a:ext>
             </a:extLst>
           </p:cNvPr>
@@ -3522,7 +3522,7 @@
           <p:cNvPr id="6" name="">
             <a:extLst xmlns:a="http://schemas.openxmlformats.org/drawingml/2006/main">
               <a:ext uri="{FF2B5EF4-FFF2-40B4-BE49-F238E27FC236}">
-                <a16:creationId xmlns:a16="http://schemas.microsoft.com/office/drawing/2014/main" id="{9220A7B7-5980-4B23-914A-778F2BF1AA9B}"/>
+                <a16:creationId xmlns:a16="http://schemas.microsoft.com/office/drawing/2014/main" id="{E9397BF8-DE32-4D66-8FD2-77DA2402FA5A}"/>
               </a:ext>
             </a:extLst>
           </p:cNvPr>
@@ -3553,7 +3553,7 @@
           <p:cNvPr id="7" name="">
             <a:extLst xmlns:a="http://schemas.openxmlformats.org/drawingml/2006/main">
               <a:ext uri="{FF2B5EF4-FFF2-40B4-BE49-F238E27FC236}">
-                <a16:creationId xmlns:a16="http://schemas.microsoft.com/office/drawing/2014/main" id="{26B5807E-F844-4277-A7BF-46C212BC8F1F}"/>
+                <a16:creationId xmlns:a16="http://schemas.microsoft.com/office/drawing/2014/main" id="{0A7B9322-22C1-4BAA-8CC1-D87BEF0448EE}"/>
               </a:ext>
             </a:extLst>
           </p:cNvPr>
@@ -3614,7 +3614,7 @@
           <p:cNvPr id="8" name="">
             <a:extLst xmlns:a="http://schemas.openxmlformats.org/drawingml/2006/main">
               <a:ext uri="{FF2B5EF4-FFF2-40B4-BE49-F238E27FC236}">
-                <a16:creationId xmlns:a16="http://schemas.microsoft.com/office/drawing/2014/main" id="{067F6402-5C88-4C82-8E23-C63B486708B7}"/>
+                <a16:creationId xmlns:a16="http://schemas.microsoft.com/office/drawing/2014/main" id="{766E00AC-FD6B-4991-B3F7-9BB33A9C5ECF}"/>
               </a:ext>
             </a:extLst>
           </p:cNvPr>
@@ -3673,7 +3673,7 @@
     </p:spTree>
     <p:extLst>
       <p:ext uri="{BB962C8B-B14F-4D97-AF65-F5344CB8AC3E}">
-        <p14:creationId xmlns:p14="http://schemas.microsoft.com/office/powerpoint/2010/main" val="1655308722"/>
+        <p14:creationId xmlns:p14="http://schemas.microsoft.com/office/powerpoint/2010/main" val="139452319"/>
       </p:ext>
     </p:extLst>
   </p:cSld>
@@ -3704,7 +3704,7 @@
           <p:cNvPr id="7" name="">
             <a:extLst xmlns:a="http://schemas.openxmlformats.org/drawingml/2006/main">
               <a:ext uri="{FF2B5EF4-FFF2-40B4-BE49-F238E27FC236}">
-                <a16:creationId xmlns:a16="http://schemas.microsoft.com/office/drawing/2014/main" id="{AFE0D27F-C6E5-4C8F-8D2F-FBE13C527489}"/>
+                <a16:creationId xmlns:a16="http://schemas.microsoft.com/office/drawing/2014/main" id="{ACC34600-B9CE-4FF1-AF8A-AAC7C28BDAEA}"/>
               </a:ext>
             </a:extLst>
           </p:cNvPr>
@@ -3792,7 +3792,7 @@
           <p:cNvPr id="2" name="">
             <a:extLst xmlns:a="http://schemas.openxmlformats.org/drawingml/2006/main">
               <a:ext uri="{FF2B5EF4-FFF2-40B4-BE49-F238E27FC236}">
-                <a16:creationId xmlns:a16="http://schemas.microsoft.com/office/drawing/2014/main" id="{988B0D8C-C6C8-4E75-B190-FF56D49EF15B}"/>
+                <a16:creationId xmlns:a16="http://schemas.microsoft.com/office/drawing/2014/main" id="{B58C2D1A-186D-4DC6-AA22-81C75ED870FF}"/>
               </a:ext>
             </a:extLst>
           </p:cNvPr>
@@ -3853,7 +3853,7 @@
           <p:cNvPr id="3" name="">
             <a:extLst xmlns:a="http://schemas.openxmlformats.org/drawingml/2006/main">
               <a:ext uri="{FF2B5EF4-FFF2-40B4-BE49-F238E27FC236}">
-                <a16:creationId xmlns:a16="http://schemas.microsoft.com/office/drawing/2014/main" id="{2BC7B6B4-FAD3-4D43-919F-169615DD95E5}"/>
+                <a16:creationId xmlns:a16="http://schemas.microsoft.com/office/drawing/2014/main" id="{39F1A3B6-7544-442B-BC46-E817C502C361}"/>
               </a:ext>
             </a:extLst>
           </p:cNvPr>
@@ -3884,7 +3884,7 @@
           <p:cNvPr id="4" name="">
             <a:extLst xmlns:a="http://schemas.openxmlformats.org/drawingml/2006/main">
               <a:ext uri="{FF2B5EF4-FFF2-40B4-BE49-F238E27FC236}">
-                <a16:creationId xmlns:a16="http://schemas.microsoft.com/office/drawing/2014/main" id="{8C70D0BE-3001-4537-AA1D-88C26FCE8B31}"/>
+                <a16:creationId xmlns:a16="http://schemas.microsoft.com/office/drawing/2014/main" id="{5A9BED04-B509-4EA3-8B89-E337333EBE7B}"/>
               </a:ext>
             </a:extLst>
           </p:cNvPr>
@@ -3945,7 +3945,7 @@
           <p:cNvPr id="5" name="">
             <a:extLst xmlns:a="http://schemas.openxmlformats.org/drawingml/2006/main">
               <a:ext uri="{FF2B5EF4-FFF2-40B4-BE49-F238E27FC236}">
-                <a16:creationId xmlns:a16="http://schemas.microsoft.com/office/drawing/2014/main" id="{EDFD2559-340C-4634-B270-9F3E3A8843C2}"/>
+                <a16:creationId xmlns:a16="http://schemas.microsoft.com/office/drawing/2014/main" id="{0FA6A05D-69CA-4C94-9F5E-32EAFD9B1CBD}"/>
               </a:ext>
             </a:extLst>
           </p:cNvPr>
@@ -4006,7 +4006,7 @@
           <p:cNvPr id="6" name="">
             <a:extLst xmlns:a="http://schemas.openxmlformats.org/drawingml/2006/main">
               <a:ext uri="{FF2B5EF4-FFF2-40B4-BE49-F238E27FC236}">
-                <a16:creationId xmlns:a16="http://schemas.microsoft.com/office/drawing/2014/main" id="{86EB4BB9-9BF5-4DC5-A5B3-757EDF931329}"/>
+                <a16:creationId xmlns:a16="http://schemas.microsoft.com/office/drawing/2014/main" id="{D629DC58-F910-41B1-8D4A-280470BFE220}"/>
               </a:ext>
             </a:extLst>
           </p:cNvPr>
@@ -4065,7 +4065,7 @@
     </p:spTree>
     <p:extLst>
       <p:ext uri="{BB962C8B-B14F-4D97-AF65-F5344CB8AC3E}">
-        <p14:creationId xmlns:p14="http://schemas.microsoft.com/office/powerpoint/2010/main" val="250888838"/>
+        <p14:creationId xmlns:p14="http://schemas.microsoft.com/office/powerpoint/2010/main" val="1494971778"/>
       </p:ext>
     </p:extLst>
   </p:cSld>
@@ -4096,7 +4096,7 @@
           <p:cNvPr id="7" name="">
             <a:extLst xmlns:a="http://schemas.openxmlformats.org/drawingml/2006/main">
               <a:ext uri="{FF2B5EF4-FFF2-40B4-BE49-F238E27FC236}">
-                <a16:creationId xmlns:a16="http://schemas.microsoft.com/office/drawing/2014/main" id="{D32714DF-FC78-4F42-A86A-6B522CE2298C}"/>
+                <a16:creationId xmlns:a16="http://schemas.microsoft.com/office/drawing/2014/main" id="{1A8C38B0-486B-43EB-B5AF-3F7F005BC635}"/>
               </a:ext>
             </a:extLst>
           </p:cNvPr>
@@ -4157,7 +4157,7 @@
           <p:cNvPr id="2" name="">
             <a:extLst xmlns:a="http://schemas.openxmlformats.org/drawingml/2006/main">
               <a:ext uri="{FF2B5EF4-FFF2-40B4-BE49-F238E27FC236}">
-                <a16:creationId xmlns:a16="http://schemas.microsoft.com/office/drawing/2014/main" id="{A85C32D0-E355-4187-B9F8-5452A113036E}"/>
+                <a16:creationId xmlns:a16="http://schemas.microsoft.com/office/drawing/2014/main" id="{D29C15CD-0D8E-402B-A5DF-A5BCEA738BAC}"/>
               </a:ext>
             </a:extLst>
           </p:cNvPr>
@@ -4222,7 +4222,7 @@
           <p:nvPr/>
         </p:nvPicPr>
         <p:blipFill>
-          <a:blip xmlns:r="http://schemas.openxmlformats.org/officeDocument/2006/relationships" xmlns:a="http://schemas.openxmlformats.org/drawingml/2006/main" r:embed="R346cfb3b2cd9432a"/>
+          <a:blip xmlns:r="http://schemas.openxmlformats.org/officeDocument/2006/relationships" xmlns:a="http://schemas.openxmlformats.org/drawingml/2006/main" r:embed="R2d30f9c78bbc418c"/>
           <a:stretch xmlns:a="http://schemas.openxmlformats.org/drawingml/2006/main"/>
         </p:blipFill>
         <p:spPr>
@@ -4244,7 +4244,7 @@
           <p:nvPr/>
         </p:nvPicPr>
         <p:blipFill>
-          <a:blip xmlns:r="http://schemas.openxmlformats.org/officeDocument/2006/relationships" xmlns:a="http://schemas.openxmlformats.org/drawingml/2006/main" r:embed="R4874b09f70e74322"/>
+          <a:blip xmlns:r="http://schemas.openxmlformats.org/officeDocument/2006/relationships" xmlns:a="http://schemas.openxmlformats.org/drawingml/2006/main" r:embed="R183a7648856a4b63"/>
           <a:stretch xmlns:a="http://schemas.openxmlformats.org/drawingml/2006/main"/>
         </p:blipFill>
         <p:spPr>
@@ -4262,7 +4262,7 @@
           <p:cNvPr id="5" name="">
             <a:extLst xmlns:a="http://schemas.openxmlformats.org/drawingml/2006/main">
               <a:ext uri="{FF2B5EF4-FFF2-40B4-BE49-F238E27FC236}">
-                <a16:creationId xmlns:a16="http://schemas.microsoft.com/office/drawing/2014/main" id="{F571D127-86EB-461B-AA65-F3F3E4830239}"/>
+                <a16:creationId xmlns:a16="http://schemas.microsoft.com/office/drawing/2014/main" id="{3123077F-B651-435B-B8CF-79842F0C44D2}"/>
               </a:ext>
             </a:extLst>
           </p:cNvPr>
@@ -4323,7 +4323,7 @@
           <p:cNvPr id="6" name="">
             <a:extLst xmlns:a="http://schemas.openxmlformats.org/drawingml/2006/main">
               <a:ext uri="{FF2B5EF4-FFF2-40B4-BE49-F238E27FC236}">
-                <a16:creationId xmlns:a16="http://schemas.microsoft.com/office/drawing/2014/main" id="{3D9E8488-E8C9-4FA7-933B-C9125744EE98}"/>
+                <a16:creationId xmlns:a16="http://schemas.microsoft.com/office/drawing/2014/main" id="{BABA63EC-C9AC-47B3-A76A-338DADFA5953}"/>
               </a:ext>
             </a:extLst>
           </p:cNvPr>
@@ -4382,7 +4382,7 @@
     </p:spTree>
     <p:extLst>
       <p:ext uri="{BB962C8B-B14F-4D97-AF65-F5344CB8AC3E}">
-        <p14:creationId xmlns:p14="http://schemas.microsoft.com/office/powerpoint/2010/main" val="654863258"/>
+        <p14:creationId xmlns:p14="http://schemas.microsoft.com/office/powerpoint/2010/main" val="1157140983"/>
       </p:ext>
     </p:extLst>
   </p:cSld>
@@ -4413,7 +4413,7 @@
           <p:cNvPr id="9" name="">
             <a:extLst xmlns:a="http://schemas.openxmlformats.org/drawingml/2006/main">
               <a:ext uri="{FF2B5EF4-FFF2-40B4-BE49-F238E27FC236}">
-                <a16:creationId xmlns:a16="http://schemas.microsoft.com/office/drawing/2014/main" id="{01EA762B-21DE-4FAD-A772-0DD15FC253DB}"/>
+                <a16:creationId xmlns:a16="http://schemas.microsoft.com/office/drawing/2014/main" id="{8EAC7D0B-A9FC-400C-B658-1F26CA748368}"/>
               </a:ext>
             </a:extLst>
           </p:cNvPr>
@@ -4474,7 +4474,7 @@
           <p:cNvPr id="2" name="">
             <a:extLst xmlns:a="http://schemas.openxmlformats.org/drawingml/2006/main">
               <a:ext uri="{FF2B5EF4-FFF2-40B4-BE49-F238E27FC236}">
-                <a16:creationId xmlns:a16="http://schemas.microsoft.com/office/drawing/2014/main" id="{FCA332BC-F102-480B-8DA7-44CA9497546D}"/>
+                <a16:creationId xmlns:a16="http://schemas.microsoft.com/office/drawing/2014/main" id="{25478157-4254-4B02-99A9-8CA65D18593C}"/>
               </a:ext>
             </a:extLst>
           </p:cNvPr>
@@ -4535,7 +4535,7 @@
           <p:cNvPr id="3" name="">
             <a:extLst xmlns:a="http://schemas.openxmlformats.org/drawingml/2006/main">
               <a:ext uri="{FF2B5EF4-FFF2-40B4-BE49-F238E27FC236}">
-                <a16:creationId xmlns:a16="http://schemas.microsoft.com/office/drawing/2014/main" id="{9F07D349-C7C1-4A68-9C60-1D9EE44D8769}"/>
+                <a16:creationId xmlns:a16="http://schemas.microsoft.com/office/drawing/2014/main" id="{D2BA45CE-1EE2-4E03-8B71-A70FE4B61A6C}"/>
               </a:ext>
             </a:extLst>
           </p:cNvPr>
@@ -4596,7 +4596,7 @@
           <p:cNvPr id="4" name="">
             <a:extLst xmlns:a="http://schemas.openxmlformats.org/drawingml/2006/main">
               <a:ext uri="{FF2B5EF4-FFF2-40B4-BE49-F238E27FC236}">
-                <a16:creationId xmlns:a16="http://schemas.microsoft.com/office/drawing/2014/main" id="{9C9359AE-5EE0-4059-8497-A2C32C8EC525}"/>
+                <a16:creationId xmlns:a16="http://schemas.microsoft.com/office/drawing/2014/main" id="{6F3ACFD9-127F-4F72-AFD6-CC3353A13764}"/>
               </a:ext>
             </a:extLst>
           </p:cNvPr>
@@ -4657,7 +4657,7 @@
           <p:cNvPr id="5" name="">
             <a:extLst xmlns:a="http://schemas.openxmlformats.org/drawingml/2006/main">
               <a:ext uri="{FF2B5EF4-FFF2-40B4-BE49-F238E27FC236}">
-                <a16:creationId xmlns:a16="http://schemas.microsoft.com/office/drawing/2014/main" id="{AB271474-225F-4D83-B710-6F14443480FC}"/>
+                <a16:creationId xmlns:a16="http://schemas.microsoft.com/office/drawing/2014/main" id="{80C5EC4A-1B61-41B0-A190-9F607AB03421}"/>
               </a:ext>
             </a:extLst>
           </p:cNvPr>
@@ -4718,7 +4718,7 @@
           <p:cNvPr id="6" name="">
             <a:extLst xmlns:a="http://schemas.openxmlformats.org/drawingml/2006/main">
               <a:ext uri="{FF2B5EF4-FFF2-40B4-BE49-F238E27FC236}">
-                <a16:creationId xmlns:a16="http://schemas.microsoft.com/office/drawing/2014/main" id="{BE5D868A-2948-4B84-9A46-B0989B7A4609}"/>
+                <a16:creationId xmlns:a16="http://schemas.microsoft.com/office/drawing/2014/main" id="{EA307746-727B-4780-A219-408746DA9BC6}"/>
               </a:ext>
             </a:extLst>
           </p:cNvPr>
@@ -4749,7 +4749,7 @@
           <p:cNvPr id="7" name="">
             <a:extLst xmlns:a="http://schemas.openxmlformats.org/drawingml/2006/main">
               <a:ext uri="{FF2B5EF4-FFF2-40B4-BE49-F238E27FC236}">
-                <a16:creationId xmlns:a16="http://schemas.microsoft.com/office/drawing/2014/main" id="{E96C6215-171C-4C78-92E5-9897E0F083F4}"/>
+                <a16:creationId xmlns:a16="http://schemas.microsoft.com/office/drawing/2014/main" id="{64F79C15-D85D-4277-A4D5-8AD607E9BD19}"/>
               </a:ext>
             </a:extLst>
           </p:cNvPr>
@@ -4780,7 +4780,7 @@
           <p:cNvPr id="8" name="">
             <a:extLst xmlns:a="http://schemas.openxmlformats.org/drawingml/2006/main">
               <a:ext uri="{FF2B5EF4-FFF2-40B4-BE49-F238E27FC236}">
-                <a16:creationId xmlns:a16="http://schemas.microsoft.com/office/drawing/2014/main" id="{656D69A7-9EB2-4B3D-A838-184B6E2E666F}"/>
+                <a16:creationId xmlns:a16="http://schemas.microsoft.com/office/drawing/2014/main" id="{CDE18514-6CA9-46F6-A4F6-A7B2A390D50B}"/>
               </a:ext>
             </a:extLst>
           </p:cNvPr>
@@ -4839,7 +4839,7 @@
     </p:spTree>
     <p:extLst>
       <p:ext uri="{BB962C8B-B14F-4D97-AF65-F5344CB8AC3E}">
-        <p14:creationId xmlns:p14="http://schemas.microsoft.com/office/powerpoint/2010/main" val="1757712423"/>
+        <p14:creationId xmlns:p14="http://schemas.microsoft.com/office/powerpoint/2010/main" val="1234784675"/>
       </p:ext>
     </p:extLst>
   </p:cSld>
@@ -4870,7 +4870,7 @@
           <p:cNvPr id="7" name="">
             <a:extLst xmlns:a="http://schemas.openxmlformats.org/drawingml/2006/main">
               <a:ext uri="{FF2B5EF4-FFF2-40B4-BE49-F238E27FC236}">
-                <a16:creationId xmlns:a16="http://schemas.microsoft.com/office/drawing/2014/main" id="{4E2C3B48-9038-4518-8577-21EF243516D7}"/>
+                <a16:creationId xmlns:a16="http://schemas.microsoft.com/office/drawing/2014/main" id="{28D6AAA1-E276-43ED-B9A0-CF521C4A6D8F}"/>
               </a:ext>
             </a:extLst>
           </p:cNvPr>
@@ -4931,7 +4931,7 @@
           <p:cNvPr id="2" name="">
             <a:extLst xmlns:a="http://schemas.openxmlformats.org/drawingml/2006/main">
               <a:ext uri="{FF2B5EF4-FFF2-40B4-BE49-F238E27FC236}">
-                <a16:creationId xmlns:a16="http://schemas.microsoft.com/office/drawing/2014/main" id="{AA9BD1E0-7A48-4526-BF76-41D38EFB8169}"/>
+                <a16:creationId xmlns:a16="http://schemas.microsoft.com/office/drawing/2014/main" id="{EBD4C7A6-9515-4A81-8538-DCAC5475D615}"/>
               </a:ext>
             </a:extLst>
           </p:cNvPr>
@@ -4992,7 +4992,7 @@
           <p:cNvPr id="3" name="">
             <a:extLst xmlns:a="http://schemas.openxmlformats.org/drawingml/2006/main">
               <a:ext uri="{FF2B5EF4-FFF2-40B4-BE49-F238E27FC236}">
-                <a16:creationId xmlns:a16="http://schemas.microsoft.com/office/drawing/2014/main" id="{D1545B00-E0D6-40A1-BE71-7A3AC59DD25E}"/>
+                <a16:creationId xmlns:a16="http://schemas.microsoft.com/office/drawing/2014/main" id="{71F7941D-E6C8-4E9A-A2D3-9BBAE732CF8A}"/>
               </a:ext>
             </a:extLst>
           </p:cNvPr>
@@ -5104,7 +5104,7 @@
           <p:nvPr/>
         </p:nvPicPr>
         <p:blipFill>
-          <a:blip xmlns:r="http://schemas.openxmlformats.org/officeDocument/2006/relationships" xmlns:a="http://schemas.openxmlformats.org/drawingml/2006/main" r:embed="R53f41f50fed94bca"/>
+          <a:blip xmlns:r="http://schemas.openxmlformats.org/officeDocument/2006/relationships" xmlns:a="http://schemas.openxmlformats.org/drawingml/2006/main" r:embed="Rd513199e9f9842fd"/>
           <a:stretch xmlns:a="http://schemas.openxmlformats.org/drawingml/2006/main"/>
         </p:blipFill>
         <p:spPr>
@@ -5122,7 +5122,7 @@
           <p:cNvPr id="5" name="">
             <a:extLst xmlns:a="http://schemas.openxmlformats.org/drawingml/2006/main">
               <a:ext uri="{FF2B5EF4-FFF2-40B4-BE49-F238E27FC236}">
-                <a16:creationId xmlns:a16="http://schemas.microsoft.com/office/drawing/2014/main" id="{B1940849-4C3B-4828-BA83-CA75ED966822}"/>
+                <a16:creationId xmlns:a16="http://schemas.microsoft.com/office/drawing/2014/main" id="{3B76011A-3C0D-4A3F-982C-31B060CA74FF}"/>
               </a:ext>
             </a:extLst>
           </p:cNvPr>
@@ -5183,7 +5183,7 @@
           <p:cNvPr id="6" name="">
             <a:extLst xmlns:a="http://schemas.openxmlformats.org/drawingml/2006/main">
               <a:ext uri="{FF2B5EF4-FFF2-40B4-BE49-F238E27FC236}">
-                <a16:creationId xmlns:a16="http://schemas.microsoft.com/office/drawing/2014/main" id="{41AEBE2D-1EA9-49A7-BD43-30A6C78EC9CE}"/>
+                <a16:creationId xmlns:a16="http://schemas.microsoft.com/office/drawing/2014/main" id="{CFCF97AB-5D83-4812-8488-6401ABBE906D}"/>
               </a:ext>
             </a:extLst>
           </p:cNvPr>
@@ -5242,7 +5242,7 @@
     </p:spTree>
     <p:extLst>
       <p:ext uri="{BB962C8B-B14F-4D97-AF65-F5344CB8AC3E}">
-        <p14:creationId xmlns:p14="http://schemas.microsoft.com/office/powerpoint/2010/main" val="84052885"/>
+        <p14:creationId xmlns:p14="http://schemas.microsoft.com/office/powerpoint/2010/main" val="1170210960"/>
       </p:ext>
     </p:extLst>
   </p:cSld>
@@ -5273,7 +5273,7 @@
           <p:cNvPr id="10" name="">
             <a:extLst xmlns:a="http://schemas.openxmlformats.org/drawingml/2006/main">
               <a:ext uri="{FF2B5EF4-FFF2-40B4-BE49-F238E27FC236}">
-                <a16:creationId xmlns:a16="http://schemas.microsoft.com/office/drawing/2014/main" id="{42A9B008-C21C-42E8-A15D-36C13E8A6E5D}"/>
+                <a16:creationId xmlns:a16="http://schemas.microsoft.com/office/drawing/2014/main" id="{C5FB4DB3-B26D-4B06-9B79-7710772DD730}"/>
               </a:ext>
             </a:extLst>
           </p:cNvPr>
@@ -5334,7 +5334,7 @@
           <p:cNvPr id="2" name="">
             <a:extLst xmlns:a="http://schemas.openxmlformats.org/drawingml/2006/main">
               <a:ext uri="{FF2B5EF4-FFF2-40B4-BE49-F238E27FC236}">
-                <a16:creationId xmlns:a16="http://schemas.microsoft.com/office/drawing/2014/main" id="{4B905A82-395B-4D0F-B4A1-8ACAEC358867}"/>
+                <a16:creationId xmlns:a16="http://schemas.microsoft.com/office/drawing/2014/main" id="{0490DB31-5EC5-460C-B062-2F862E88AFEE}"/>
               </a:ext>
             </a:extLst>
           </p:cNvPr>
@@ -5399,7 +5399,7 @@
           <p:nvPr/>
         </p:nvPicPr>
         <p:blipFill>
-          <a:blip xmlns:r="http://schemas.openxmlformats.org/officeDocument/2006/relationships" xmlns:a="http://schemas.openxmlformats.org/drawingml/2006/main" r:embed="R3b516822882f4bc6"/>
+          <a:blip xmlns:r="http://schemas.openxmlformats.org/officeDocument/2006/relationships" xmlns:a="http://schemas.openxmlformats.org/drawingml/2006/main" r:embed="R9e8d0caa72204c72"/>
           <a:stretch xmlns:a="http://schemas.openxmlformats.org/drawingml/2006/main"/>
         </p:blipFill>
         <p:spPr>
@@ -5421,7 +5421,7 @@
           <p:nvPr/>
         </p:nvPicPr>
         <p:blipFill>
-          <a:blip xmlns:r="http://schemas.openxmlformats.org/officeDocument/2006/relationships" xmlns:a="http://schemas.openxmlformats.org/drawingml/2006/main" r:embed="Re043f6751d694ad0"/>
+          <a:blip xmlns:r="http://schemas.openxmlformats.org/officeDocument/2006/relationships" xmlns:a="http://schemas.openxmlformats.org/drawingml/2006/main" r:embed="Rb8d514153eda413b"/>
           <a:stretch xmlns:a="http://schemas.openxmlformats.org/drawingml/2006/main"/>
         </p:blipFill>
         <p:spPr>
@@ -5443,7 +5443,7 @@
           <p:nvPr/>
         </p:nvPicPr>
         <p:blipFill>
-          <a:blip xmlns:r="http://schemas.openxmlformats.org/officeDocument/2006/relationships" xmlns:a="http://schemas.openxmlformats.org/drawingml/2006/main" r:embed="R31feb34ff7164a26"/>
+          <a:blip xmlns:r="http://schemas.openxmlformats.org/officeDocument/2006/relationships" xmlns:a="http://schemas.openxmlformats.org/drawingml/2006/main" r:embed="R24232511e72b4d59"/>
           <a:stretch xmlns:a="http://schemas.openxmlformats.org/drawingml/2006/main"/>
         </p:blipFill>
         <p:spPr>
@@ -5461,7 +5461,7 @@
           <p:cNvPr id="6" name="">
             <a:extLst xmlns:a="http://schemas.openxmlformats.org/drawingml/2006/main">
               <a:ext uri="{FF2B5EF4-FFF2-40B4-BE49-F238E27FC236}">
-                <a16:creationId xmlns:a16="http://schemas.microsoft.com/office/drawing/2014/main" id="{93D6CB6A-A24E-4126-A46D-33ECFF0B006E}"/>
+                <a16:creationId xmlns:a16="http://schemas.microsoft.com/office/drawing/2014/main" id="{B01DDDD1-07ED-4E4A-9E16-C2DFB837E529}"/>
               </a:ext>
             </a:extLst>
           </p:cNvPr>
@@ -5522,7 +5522,7 @@
           <p:cNvPr id="7" name="">
             <a:extLst xmlns:a="http://schemas.openxmlformats.org/drawingml/2006/main">
               <a:ext uri="{FF2B5EF4-FFF2-40B4-BE49-F238E27FC236}">
-                <a16:creationId xmlns:a16="http://schemas.microsoft.com/office/drawing/2014/main" id="{B69C8D19-EA5C-49EF-9BF1-19F5011402DE}"/>
+                <a16:creationId xmlns:a16="http://schemas.microsoft.com/office/drawing/2014/main" id="{663275CA-A954-4A99-AAB1-38A801FDC2FE}"/>
               </a:ext>
             </a:extLst>
           </p:cNvPr>
@@ -5583,7 +5583,7 @@
           <p:cNvPr id="8" name="">
             <a:extLst xmlns:a="http://schemas.openxmlformats.org/drawingml/2006/main">
               <a:ext uri="{FF2B5EF4-FFF2-40B4-BE49-F238E27FC236}">
-                <a16:creationId xmlns:a16="http://schemas.microsoft.com/office/drawing/2014/main" id="{C08B548F-FAB5-4007-9930-EEE24332C29E}"/>
+                <a16:creationId xmlns:a16="http://schemas.microsoft.com/office/drawing/2014/main" id="{D183A928-5404-4314-BCB6-0BC462227B96}"/>
               </a:ext>
             </a:extLst>
           </p:cNvPr>
@@ -5644,7 +5644,7 @@
           <p:cNvPr id="9" name="">
             <a:extLst xmlns:a="http://schemas.openxmlformats.org/drawingml/2006/main">
               <a:ext uri="{FF2B5EF4-FFF2-40B4-BE49-F238E27FC236}">
-                <a16:creationId xmlns:a16="http://schemas.microsoft.com/office/drawing/2014/main" id="{851CC703-D5CB-4F65-AC4A-06D16CA7A3DC}"/>
+                <a16:creationId xmlns:a16="http://schemas.microsoft.com/office/drawing/2014/main" id="{CFFBB5C2-B6BB-4526-AF58-0E773E7B50F5}"/>
               </a:ext>
             </a:extLst>
           </p:cNvPr>
@@ -5703,7 +5703,7 @@
     </p:spTree>
     <p:extLst>
       <p:ext uri="{BB962C8B-B14F-4D97-AF65-F5344CB8AC3E}">
-        <p14:creationId xmlns:p14="http://schemas.microsoft.com/office/powerpoint/2010/main" val="1215291210"/>
+        <p14:creationId xmlns:p14="http://schemas.microsoft.com/office/powerpoint/2010/main" val="989749100"/>
       </p:ext>
     </p:extLst>
   </p:cSld>
@@ -5731,10 +5731,10 @@
       </p:grpSpPr>
       <p:sp>
         <p:nvSpPr>
-          <p:cNvPr id="6" name="">
+          <p:cNvPr id="10" name="">
             <a:extLst xmlns:a="http://schemas.openxmlformats.org/drawingml/2006/main">
               <a:ext uri="{FF2B5EF4-FFF2-40B4-BE49-F238E27FC236}">
-                <a16:creationId xmlns:a16="http://schemas.microsoft.com/office/drawing/2014/main" id="{D1E82359-3052-417A-89FA-42BB4B08CD42}"/>
+                <a16:creationId xmlns:a16="http://schemas.microsoft.com/office/drawing/2014/main" id="{833E4A45-45C8-4DEB-A483-A36434B0D675}"/>
               </a:ext>
             </a:extLst>
           </p:cNvPr>
@@ -5785,7 +5785,7 @@
                 <a:ea typeface="Helvetica Neue"/>
                 <a:cs typeface="Helvetica Neue"/>
               </a:rPr>
-              <a:t>Why run AI locally?</a:t>
+              <a:t>Why can local AI feel free?</a:t>
             </a:r>
           </a:p>
         </p:txBody>
@@ -5795,7 +5795,7 @@
           <p:cNvPr id="2" name="">
             <a:extLst xmlns:a="http://schemas.openxmlformats.org/drawingml/2006/main">
               <a:ext uri="{FF2B5EF4-FFF2-40B4-BE49-F238E27FC236}">
-                <a16:creationId xmlns:a16="http://schemas.microsoft.com/office/drawing/2014/main" id="{EFDA4337-6FC8-4DF4-B3F9-2D4A6B143D8C}"/>
+                <a16:creationId xmlns:a16="http://schemas.microsoft.com/office/drawing/2014/main" id="{853EE5B5-C239-4312-889C-6A3C41EF7206}"/>
               </a:ext>
             </a:extLst>
           </p:cNvPr>
@@ -5856,7 +5856,7 @@
           <p:cNvPr id="3" name="">
             <a:extLst xmlns:a="http://schemas.openxmlformats.org/drawingml/2006/main">
               <a:ext uri="{FF2B5EF4-FFF2-40B4-BE49-F238E27FC236}">
-                <a16:creationId xmlns:a16="http://schemas.microsoft.com/office/drawing/2014/main" id="{87696321-D688-4E4E-B61E-A8A066D9F207}"/>
+                <a16:creationId xmlns:a16="http://schemas.microsoft.com/office/drawing/2014/main" id="{FEC26742-4D33-422B-85A0-F0624A9452C2}"/>
               </a:ext>
             </a:extLst>
           </p:cNvPr>
@@ -5867,8 +5867,8 @@
         </p:nvSpPr>
         <p:spPr>
           <a:xfrm xmlns:a="http://schemas.openxmlformats.org/drawingml/2006/main">
-            <a:off x="742950" y="1695450"/>
-            <a:ext cx="10477500" cy="685800"/>
+            <a:off x="762000" y="1714500"/>
+            <a:ext cx="4762500" cy="400050"/>
           </a:xfrm>
           <a:prstGeom xmlns:a="http://schemas.openxmlformats.org/drawingml/2006/main" prst="rect">
             <a:avLst/>
@@ -5889,7 +5889,7 @@
                 <a:spcPct val="100000"/>
               </a:lnSpc>
               <a:buNone/>
-              <a:defRPr sz="2550" b="1">
+              <a:defRPr sz="1425" b="1">
                 <a:solidFill>
                   <a:srgbClr val="6558F5"/>
                 </a:solidFill>
@@ -5899,7 +5899,7 @@
               </a:defRPr>
             </a:pPr>
             <a:r>
-              <a:rPr sz="2550" b="1">
+              <a:rPr sz="1425" b="1">
                 <a:solidFill>
                   <a:srgbClr val="6558F5"/>
                 </a:solidFill>
@@ -5907,7 +5907,7 @@
                 <a:ea typeface="Helvetica Neue"/>
                 <a:cs typeface="Helvetica Neue"/>
               </a:rPr>
-              <a:t>MORE CONTROL</a:t>
+              <a:t>WHAT CHANGES</a:t>
             </a:r>
           </a:p>
         </p:txBody>
@@ -5917,7 +5917,7 @@
           <p:cNvPr id="4" name="">
             <a:extLst xmlns:a="http://schemas.openxmlformats.org/drawingml/2006/main">
               <a:ext uri="{FF2B5EF4-FFF2-40B4-BE49-F238E27FC236}">
-                <a16:creationId xmlns:a16="http://schemas.microsoft.com/office/drawing/2014/main" id="{9CC4C7F0-2CA1-4171-A271-7726E436757B}"/>
+                <a16:creationId xmlns:a16="http://schemas.microsoft.com/office/drawing/2014/main" id="{D660F3C8-5A56-499A-9067-7E5EC4303322}"/>
               </a:ext>
             </a:extLst>
           </p:cNvPr>
@@ -5928,8 +5928,8 @@
         </p:nvSpPr>
         <p:spPr>
           <a:xfrm xmlns:a="http://schemas.openxmlformats.org/drawingml/2006/main">
-            <a:off x="742950" y="2457450"/>
-            <a:ext cx="10001250" cy="2000250"/>
+            <a:off x="762000" y="2286000"/>
+            <a:ext cx="4762500" cy="2333625"/>
           </a:xfrm>
           <a:prstGeom xmlns:a="http://schemas.openxmlformats.org/drawingml/2006/main" prst="rect">
             <a:avLst/>
@@ -5947,10 +5947,10 @@
           <a:p xmlns:a="http://schemas.openxmlformats.org/drawingml/2006/main">
             <a:pPr algn="l">
               <a:lnSpc>
-                <a:spcPct val="95000"/>
+                <a:spcPct val="98000"/>
               </a:lnSpc>
               <a:buNone/>
-              <a:defRPr sz="5700" b="1">
+              <a:defRPr sz="3825" b="1">
                 <a:solidFill>
                   <a:srgbClr val="101114"/>
                 </a:solidFill>
@@ -5960,7 +5960,7 @@
               </a:defRPr>
             </a:pPr>
             <a:r>
-              <a:rPr sz="5700" b="1">
+              <a:rPr sz="3825" b="1">
                 <a:solidFill>
                   <a:srgbClr val="101114"/>
                 </a:solidFill>
@@ -5968,16 +5968,16 @@
                 <a:ea typeface="Helvetica Neue"/>
                 <a:cs typeface="Helvetica Neue"/>
               </a:rPr>
-              <a:t>without a meter</a:t>
+              <a:t>Your computer</a:t>
             </a:r>
           </a:p>
           <a:p xmlns:a="http://schemas.openxmlformats.org/drawingml/2006/main">
             <a:pPr algn="l">
               <a:lnSpc>
-                <a:spcPct val="95000"/>
+                <a:spcPct val="98000"/>
               </a:lnSpc>
               <a:buNone/>
-              <a:defRPr sz="5700" b="1">
+              <a:defRPr sz="3825" b="1">
                 <a:solidFill>
                   <a:srgbClr val="101114"/>
                 </a:solidFill>
@@ -5987,7 +5987,7 @@
               </a:defRPr>
             </a:pPr>
             <a:r>
-              <a:rPr sz="5700" b="1">
+              <a:rPr sz="3825" b="1">
                 <a:solidFill>
                   <a:srgbClr val="101114"/>
                 </a:solidFill>
@@ -5995,7 +5995,34 @@
                 <a:ea typeface="Helvetica Neue"/>
                 <a:cs typeface="Helvetica Neue"/>
               </a:rPr>
-              <a:t>running.</a:t>
+              <a:t>produces the</a:t>
+            </a:r>
+          </a:p>
+          <a:p xmlns:a="http://schemas.openxmlformats.org/drawingml/2006/main">
+            <a:pPr algn="l">
+              <a:lnSpc>
+                <a:spcPct val="98000"/>
+              </a:lnSpc>
+              <a:buNone/>
+              <a:defRPr sz="3825" b="1">
+                <a:solidFill>
+                  <a:srgbClr val="101114"/>
+                </a:solidFill>
+                <a:latin typeface="Helvetica Neue"/>
+                <a:ea typeface="Helvetica Neue"/>
+                <a:cs typeface="Helvetica Neue"/>
+              </a:defRPr>
+            </a:pPr>
+            <a:r>
+              <a:rPr sz="3825" b="1">
+                <a:solidFill>
+                  <a:srgbClr val="101114"/>
+                </a:solidFill>
+                <a:latin typeface="Helvetica Neue"/>
+                <a:ea typeface="Helvetica Neue"/>
+                <a:cs typeface="Helvetica Neue"/>
+              </a:rPr>
+              <a:t>next answer.</a:t>
             </a:r>
           </a:p>
         </p:txBody>
@@ -6005,7 +6032,7 @@
           <p:cNvPr id="5" name="">
             <a:extLst xmlns:a="http://schemas.openxmlformats.org/drawingml/2006/main">
               <a:ext uri="{FF2B5EF4-FFF2-40B4-BE49-F238E27FC236}">
-                <a16:creationId xmlns:a16="http://schemas.microsoft.com/office/drawing/2014/main" id="{D932C19D-0D4B-4D1B-8994-8EEE24C64977}"/>
+                <a16:creationId xmlns:a16="http://schemas.microsoft.com/office/drawing/2014/main" id="{963F59E3-C83F-4DC9-A28B-CFBA66FA7247}"/>
               </a:ext>
             </a:extLst>
           </p:cNvPr>
@@ -6016,8 +6043,219 @@
         </p:nvSpPr>
         <p:spPr>
           <a:xfrm xmlns:a="http://schemas.openxmlformats.org/drawingml/2006/main">
-            <a:off x="781050" y="5219700"/>
-            <a:ext cx="8572500" cy="495300"/>
+            <a:off x="6096000" y="1676400"/>
+            <a:ext cx="0" cy="3286125"/>
+          </a:xfrm>
+          <a:prstGeom xmlns:a="http://schemas.openxmlformats.org/drawingml/2006/main" prst="line">
+            <a:avLst/>
+          </a:prstGeom>
+          <a:noFill xmlns:a="http://schemas.openxmlformats.org/drawingml/2006/main"/>
+          <a:ln xmlns:a="http://schemas.openxmlformats.org/drawingml/2006/main" w="19050">
+            <a:solidFill>
+              <a:srgbClr val="CFCAC0"/>
+            </a:solidFill>
+            <a:prstDash val="solid"/>
+          </a:ln>
+        </p:spPr>
+      </p:sp>
+      <p:sp>
+        <p:nvSpPr>
+          <p:cNvPr id="6" name="">
+            <a:extLst xmlns:a="http://schemas.openxmlformats.org/drawingml/2006/main">
+              <a:ext uri="{FF2B5EF4-FFF2-40B4-BE49-F238E27FC236}">
+                <a16:creationId xmlns:a16="http://schemas.microsoft.com/office/drawing/2014/main" id="{3A007DEB-6571-4EFF-8BCB-1FB7154B2494}"/>
+              </a:ext>
+            </a:extLst>
+          </p:cNvPr>
+          <p:cNvSpPr>
+            <a:spLocks xmlns:a="http://schemas.openxmlformats.org/drawingml/2006/main" noGrp="1"/>
+          </p:cNvSpPr>
+          <p:nvPr/>
+        </p:nvSpPr>
+        <p:spPr>
+          <a:xfrm xmlns:a="http://schemas.openxmlformats.org/drawingml/2006/main">
+            <a:off x="6762750" y="1524000"/>
+            <a:ext cx="4286250" cy="1809750"/>
+          </a:xfrm>
+          <a:prstGeom xmlns:a="http://schemas.openxmlformats.org/drawingml/2006/main" prst="rect">
+            <a:avLst/>
+          </a:prstGeom>
+          <a:noFill xmlns:a="http://schemas.openxmlformats.org/drawingml/2006/main"/>
+          <a:ln xmlns:a="http://schemas.openxmlformats.org/drawingml/2006/main" w="0">
+            <a:noFill/>
+          </a:ln>
+        </p:spPr>
+        <p:txBody>
+          <a:bodyPr xmlns:a="http://schemas.openxmlformats.org/drawingml/2006/main" wrap="square" lIns="0" tIns="0" rIns="0" bIns="0" anchor="t">
+            <a:normAutofit fontScale="100000"/>
+          </a:bodyPr>
+          <a:lstStyle xmlns:a="http://schemas.openxmlformats.org/drawingml/2006/main"/>
+          <a:p xmlns:a="http://schemas.openxmlformats.org/drawingml/2006/main">
+            <a:pPr algn="ctr">
+              <a:lnSpc>
+                <a:spcPct val="100000"/>
+              </a:lnSpc>
+              <a:buNone/>
+              <a:defRPr sz="11250" b="1">
+                <a:solidFill>
+                  <a:srgbClr val="6558F5"/>
+                </a:solidFill>
+                <a:latin typeface="Helvetica Neue"/>
+                <a:ea typeface="Helvetica Neue"/>
+                <a:cs typeface="Helvetica Neue"/>
+              </a:defRPr>
+            </a:pPr>
+            <a:r>
+              <a:rPr sz="11250" b="1">
+                <a:solidFill>
+                  <a:srgbClr val="6558F5"/>
+                </a:solidFill>
+                <a:latin typeface="Helvetica Neue"/>
+                <a:ea typeface="Helvetica Neue"/>
+                <a:cs typeface="Helvetica Neue"/>
+              </a:rPr>
+              <a:t>$0</a:t>
+            </a:r>
+          </a:p>
+        </p:txBody>
+      </p:sp>
+      <p:sp>
+        <p:nvSpPr>
+          <p:cNvPr id="7" name="">
+            <a:extLst xmlns:a="http://schemas.openxmlformats.org/drawingml/2006/main">
+              <a:ext uri="{FF2B5EF4-FFF2-40B4-BE49-F238E27FC236}">
+                <a16:creationId xmlns:a16="http://schemas.microsoft.com/office/drawing/2014/main" id="{BB79B0E4-18B2-4950-BF2E-E223BA3A6221}"/>
+              </a:ext>
+            </a:extLst>
+          </p:cNvPr>
+          <p:cNvSpPr>
+            <a:spLocks xmlns:a="http://schemas.openxmlformats.org/drawingml/2006/main" noGrp="1"/>
+          </p:cNvSpPr>
+          <p:nvPr/>
+        </p:nvSpPr>
+        <p:spPr>
+          <a:xfrm xmlns:a="http://schemas.openxmlformats.org/drawingml/2006/main">
+            <a:off x="7143750" y="3352800"/>
+            <a:ext cx="3524250" cy="1047750"/>
+          </a:xfrm>
+          <a:prstGeom xmlns:a="http://schemas.openxmlformats.org/drawingml/2006/main" prst="rect">
+            <a:avLst/>
+          </a:prstGeom>
+          <a:noFill xmlns:a="http://schemas.openxmlformats.org/drawingml/2006/main"/>
+          <a:ln xmlns:a="http://schemas.openxmlformats.org/drawingml/2006/main" w="0">
+            <a:noFill/>
+          </a:ln>
+        </p:spPr>
+        <p:txBody>
+          <a:bodyPr xmlns:a="http://schemas.openxmlformats.org/drawingml/2006/main" wrap="square" lIns="0" tIns="0" rIns="0" bIns="0" anchor="t">
+            <a:normAutofit fontScale="100000"/>
+          </a:bodyPr>
+          <a:lstStyle xmlns:a="http://schemas.openxmlformats.org/drawingml/2006/main"/>
+          <a:p xmlns:a="http://schemas.openxmlformats.org/drawingml/2006/main">
+            <a:pPr algn="ctr">
+              <a:lnSpc>
+                <a:spcPct val="102000"/>
+              </a:lnSpc>
+              <a:buNone/>
+              <a:defRPr sz="2550" b="1">
+                <a:solidFill>
+                  <a:srgbClr val="101114"/>
+                </a:solidFill>
+                <a:latin typeface="Helvetica Neue"/>
+                <a:ea typeface="Helvetica Neue"/>
+                <a:cs typeface="Helvetica Neue"/>
+              </a:defRPr>
+            </a:pPr>
+            <a:r>
+              <a:rPr sz="2550" b="1">
+                <a:solidFill>
+                  <a:srgbClr val="101114"/>
+                </a:solidFill>
+                <a:latin typeface="Helvetica Neue"/>
+                <a:ea typeface="Helvetica Neue"/>
+                <a:cs typeface="Helvetica Neue"/>
+              </a:rPr>
+              <a:t>cloud charge</a:t>
+            </a:r>
+          </a:p>
+          <a:p xmlns:a="http://schemas.openxmlformats.org/drawingml/2006/main">
+            <a:pPr algn="ctr">
+              <a:lnSpc>
+                <a:spcPct val="102000"/>
+              </a:lnSpc>
+              <a:buNone/>
+              <a:defRPr sz="2550" b="1">
+                <a:solidFill>
+                  <a:srgbClr val="101114"/>
+                </a:solidFill>
+                <a:latin typeface="Helvetica Neue"/>
+                <a:ea typeface="Helvetica Neue"/>
+                <a:cs typeface="Helvetica Neue"/>
+              </a:defRPr>
+            </a:pPr>
+            <a:r>
+              <a:rPr sz="2550" b="1">
+                <a:solidFill>
+                  <a:srgbClr val="101114"/>
+                </a:solidFill>
+                <a:latin typeface="Helvetica Neue"/>
+                <a:ea typeface="Helvetica Neue"/>
+                <a:cs typeface="Helvetica Neue"/>
+              </a:rPr>
+              <a:t>for that answer</a:t>
+            </a:r>
+          </a:p>
+        </p:txBody>
+      </p:sp>
+      <p:sp>
+        <p:nvSpPr>
+          <p:cNvPr id="8" name="">
+            <a:extLst xmlns:a="http://schemas.openxmlformats.org/drawingml/2006/main">
+              <a:ext uri="{FF2B5EF4-FFF2-40B4-BE49-F238E27FC236}">
+                <a16:creationId xmlns:a16="http://schemas.microsoft.com/office/drawing/2014/main" id="{D7A47CE4-4AC4-4349-966A-5F5BE0B7CE6A}"/>
+              </a:ext>
+            </a:extLst>
+          </p:cNvPr>
+          <p:cNvSpPr>
+            <a:spLocks xmlns:a="http://schemas.openxmlformats.org/drawingml/2006/main" noGrp="1"/>
+          </p:cNvSpPr>
+          <p:nvPr/>
+        </p:nvSpPr>
+        <p:spPr>
+          <a:xfrm xmlns:a="http://schemas.openxmlformats.org/drawingml/2006/main">
+            <a:off x="762000" y="5381625"/>
+            <a:ext cx="10668000" cy="0"/>
+          </a:xfrm>
+          <a:prstGeom xmlns:a="http://schemas.openxmlformats.org/drawingml/2006/main" prst="line">
+            <a:avLst/>
+          </a:prstGeom>
+          <a:noFill xmlns:a="http://schemas.openxmlformats.org/drawingml/2006/main"/>
+          <a:ln xmlns:a="http://schemas.openxmlformats.org/drawingml/2006/main" w="28575">
+            <a:solidFill>
+              <a:srgbClr val="C96E42"/>
+            </a:solidFill>
+            <a:prstDash val="solid"/>
+          </a:ln>
+        </p:spPr>
+      </p:sp>
+      <p:sp>
+        <p:nvSpPr>
+          <p:cNvPr id="9" name="">
+            <a:extLst xmlns:a="http://schemas.openxmlformats.org/drawingml/2006/main">
+              <a:ext uri="{FF2B5EF4-FFF2-40B4-BE49-F238E27FC236}">
+                <a16:creationId xmlns:a16="http://schemas.microsoft.com/office/drawing/2014/main" id="{43A22C84-1C27-4E79-A428-067963B374C2}"/>
+              </a:ext>
+            </a:extLst>
+          </p:cNvPr>
+          <p:cNvSpPr>
+            <a:spLocks xmlns:a="http://schemas.openxmlformats.org/drawingml/2006/main" noGrp="1"/>
+          </p:cNvSpPr>
+          <p:nvPr/>
+        </p:nvSpPr>
+        <p:spPr>
+          <a:xfrm xmlns:a="http://schemas.openxmlformats.org/drawingml/2006/main">
+            <a:off x="762000" y="5619750"/>
+            <a:ext cx="10668000" cy="381000"/>
           </a:xfrm>
           <a:prstGeom xmlns:a="http://schemas.openxmlformats.org/drawingml/2006/main" prst="rect">
             <a:avLst/>
@@ -6038,7 +6276,7 @@
                 <a:spcPct val="100000"/>
               </a:lnSpc>
               <a:buNone/>
-              <a:defRPr sz="2175" b="0">
+              <a:defRPr sz="1725" b="0">
                 <a:solidFill>
                   <a:srgbClr val="74716C"/>
                 </a:solidFill>
@@ -6048,7 +6286,7 @@
               </a:defRPr>
             </a:pPr>
             <a:r>
-              <a:rPr sz="2175" b="0">
+              <a:rPr sz="1725" b="0">
                 <a:solidFill>
                   <a:srgbClr val="74716C"/>
                 </a:solidFill>
@@ -6056,7 +6294,7 @@
                 <a:ea typeface="Helvetica Neue"/>
                 <a:cs typeface="Helvetica Neue"/>
               </a:rPr>
-              <a:t>It can keep working offline.</a:t>
+              <a:t>The device and electricity still cost money.</a:t>
             </a:r>
           </a:p>
         </p:txBody>
@@ -6064,7 +6302,7 @@
     </p:spTree>
     <p:extLst>
       <p:ext uri="{BB962C8B-B14F-4D97-AF65-F5344CB8AC3E}">
-        <p14:creationId xmlns:p14="http://schemas.microsoft.com/office/powerpoint/2010/main" val="784642758"/>
+        <p14:creationId xmlns:p14="http://schemas.microsoft.com/office/powerpoint/2010/main" val="175800042"/>
       </p:ext>
     </p:extLst>
   </p:cSld>
@@ -6095,7 +6333,7 @@
           <p:cNvPr id="7" name="">
             <a:extLst xmlns:a="http://schemas.openxmlformats.org/drawingml/2006/main">
               <a:ext uri="{FF2B5EF4-FFF2-40B4-BE49-F238E27FC236}">
-                <a16:creationId xmlns:a16="http://schemas.microsoft.com/office/drawing/2014/main" id="{4D03FC64-FDF0-4A83-B49C-A4B14A52949B}"/>
+                <a16:creationId xmlns:a16="http://schemas.microsoft.com/office/drawing/2014/main" id="{E93B076E-3F5E-4D15-88AE-5479F5CE35AD}"/>
               </a:ext>
             </a:extLst>
           </p:cNvPr>
@@ -6156,7 +6394,7 @@
           <p:cNvPr id="2" name="">
             <a:extLst xmlns:a="http://schemas.openxmlformats.org/drawingml/2006/main">
               <a:ext uri="{FF2B5EF4-FFF2-40B4-BE49-F238E27FC236}">
-                <a16:creationId xmlns:a16="http://schemas.microsoft.com/office/drawing/2014/main" id="{4E7310F4-A553-4858-8344-202DCCA5AF54}"/>
+                <a16:creationId xmlns:a16="http://schemas.microsoft.com/office/drawing/2014/main" id="{8C3B9105-56B7-44C3-BD0B-268BCF17906B}"/>
               </a:ext>
             </a:extLst>
           </p:cNvPr>
@@ -6217,7 +6455,7 @@
           <p:cNvPr id="3" name="">
             <a:extLst xmlns:a="http://schemas.openxmlformats.org/drawingml/2006/main">
               <a:ext uri="{FF2B5EF4-FFF2-40B4-BE49-F238E27FC236}">
-                <a16:creationId xmlns:a16="http://schemas.microsoft.com/office/drawing/2014/main" id="{D3EA702D-2B0F-443A-BB84-27E656FA2C7B}"/>
+                <a16:creationId xmlns:a16="http://schemas.microsoft.com/office/drawing/2014/main" id="{DB603382-EBC3-497E-A9C3-AE97D83EC95B}"/>
               </a:ext>
             </a:extLst>
           </p:cNvPr>
@@ -6285,7 +6523,7 @@
         </p:xfrm>
         <a:graphic xmlns:a="http://schemas.openxmlformats.org/drawingml/2006/main">
           <a:graphicData uri="http://schemas.openxmlformats.org/drawingml/2006/chart">
-            <c:chart xmlns:r="http://schemas.openxmlformats.org/officeDocument/2006/relationships" xmlns:c="http://schemas.openxmlformats.org/drawingml/2006/chart" r:id="R1ffbef7433f74d87"/>
+            <c:chart xmlns:r="http://schemas.openxmlformats.org/officeDocument/2006/relationships" xmlns:c="http://schemas.openxmlformats.org/drawingml/2006/chart" r:id="R2d817b62d51c4716"/>
           </a:graphicData>
         </a:graphic>
       </p:graphicFrame>
@@ -6294,7 +6532,7 @@
           <p:cNvPr id="5" name="">
             <a:extLst xmlns:a="http://schemas.openxmlformats.org/drawingml/2006/main">
               <a:ext uri="{FF2B5EF4-FFF2-40B4-BE49-F238E27FC236}">
-                <a16:creationId xmlns:a16="http://schemas.microsoft.com/office/drawing/2014/main" id="{D674DCBD-9D0E-4CE3-B4F6-F3F9F066AA84}"/>
+                <a16:creationId xmlns:a16="http://schemas.microsoft.com/office/drawing/2014/main" id="{FBDC361B-C079-4509-B6BA-DC3DCA8569AD}"/>
               </a:ext>
             </a:extLst>
           </p:cNvPr>
@@ -6382,7 +6620,7 @@
           <p:cNvPr id="6" name="">
             <a:extLst xmlns:a="http://schemas.openxmlformats.org/drawingml/2006/main">
               <a:ext uri="{FF2B5EF4-FFF2-40B4-BE49-F238E27FC236}">
-                <a16:creationId xmlns:a16="http://schemas.microsoft.com/office/drawing/2014/main" id="{844712B8-02A7-4E32-BCBE-3994DBB5732E}"/>
+                <a16:creationId xmlns:a16="http://schemas.microsoft.com/office/drawing/2014/main" id="{3E5E4870-3847-4214-8AE2-B0501B05876E}"/>
               </a:ext>
             </a:extLst>
           </p:cNvPr>
@@ -6441,7 +6679,7 @@
     </p:spTree>
     <p:extLst>
       <p:ext uri="{BB962C8B-B14F-4D97-AF65-F5344CB8AC3E}">
-        <p14:creationId xmlns:p14="http://schemas.microsoft.com/office/powerpoint/2010/main" val="886034084"/>
+        <p14:creationId xmlns:p14="http://schemas.microsoft.com/office/powerpoint/2010/main" val="663064877"/>
       </p:ext>
     </p:extLst>
   </p:cSld>
@@ -6472,7 +6710,7 @@
           <p:cNvPr id="5" name="">
             <a:extLst xmlns:a="http://schemas.openxmlformats.org/drawingml/2006/main">
               <a:ext uri="{FF2B5EF4-FFF2-40B4-BE49-F238E27FC236}">
-                <a16:creationId xmlns:a16="http://schemas.microsoft.com/office/drawing/2014/main" id="{0371FD06-5F76-4586-8EE7-92D29665068D}"/>
+                <a16:creationId xmlns:a16="http://schemas.microsoft.com/office/drawing/2014/main" id="{87B555A8-D4A5-45CD-9AD1-E96A3D1E163E}"/>
               </a:ext>
             </a:extLst>
           </p:cNvPr>
@@ -6533,7 +6771,7 @@
           <p:cNvPr id="2" name="">
             <a:extLst xmlns:a="http://schemas.openxmlformats.org/drawingml/2006/main">
               <a:ext uri="{FF2B5EF4-FFF2-40B4-BE49-F238E27FC236}">
-                <a16:creationId xmlns:a16="http://schemas.microsoft.com/office/drawing/2014/main" id="{04555F19-F863-40AB-B552-D47DC3FA7309}"/>
+                <a16:creationId xmlns:a16="http://schemas.microsoft.com/office/drawing/2014/main" id="{ABC33E7A-B988-4A2B-AC43-FF8427323EB5}"/>
               </a:ext>
             </a:extLst>
           </p:cNvPr>
@@ -6594,7 +6832,7 @@
           <p:cNvPr id="3" name="">
             <a:extLst xmlns:a="http://schemas.openxmlformats.org/drawingml/2006/main">
               <a:ext uri="{FF2B5EF4-FFF2-40B4-BE49-F238E27FC236}">
-                <a16:creationId xmlns:a16="http://schemas.microsoft.com/office/drawing/2014/main" id="{918620BC-8EA1-4ED4-86C7-58F31E8514F4}"/>
+                <a16:creationId xmlns:a16="http://schemas.microsoft.com/office/drawing/2014/main" id="{2A5C662C-EFA7-4FAC-8834-3E9331626B8B}"/>
               </a:ext>
             </a:extLst>
           </p:cNvPr>
@@ -6682,7 +6920,7 @@
           <p:cNvPr id="4" name="">
             <a:extLst xmlns:a="http://schemas.openxmlformats.org/drawingml/2006/main">
               <a:ext uri="{FF2B5EF4-FFF2-40B4-BE49-F238E27FC236}">
-                <a16:creationId xmlns:a16="http://schemas.microsoft.com/office/drawing/2014/main" id="{27D193F2-2D0D-41C4-8E92-9B047DE8549B}"/>
+                <a16:creationId xmlns:a16="http://schemas.microsoft.com/office/drawing/2014/main" id="{92AE2558-0354-42A4-8F83-64012C295EAE}"/>
               </a:ext>
             </a:extLst>
           </p:cNvPr>
@@ -6711,7 +6949,7 @@
     </p:spTree>
     <p:extLst>
       <p:ext uri="{BB962C8B-B14F-4D97-AF65-F5344CB8AC3E}">
-        <p14:creationId xmlns:p14="http://schemas.microsoft.com/office/powerpoint/2010/main" val="1107780271"/>
+        <p14:creationId xmlns:p14="http://schemas.microsoft.com/office/powerpoint/2010/main" val="1134571996"/>
       </p:ext>
     </p:extLst>
   </p:cSld>
@@ -6742,7 +6980,7 @@
           <p:cNvPr id="9" name="">
             <a:extLst xmlns:a="http://schemas.openxmlformats.org/drawingml/2006/main">
               <a:ext uri="{FF2B5EF4-FFF2-40B4-BE49-F238E27FC236}">
-                <a16:creationId xmlns:a16="http://schemas.microsoft.com/office/drawing/2014/main" id="{FFE06046-7B77-4ACA-AB8E-5A8F7295EE96}"/>
+                <a16:creationId xmlns:a16="http://schemas.microsoft.com/office/drawing/2014/main" id="{2BC9BB76-4E6D-4634-9C83-35F71D13F27B}"/>
               </a:ext>
             </a:extLst>
           </p:cNvPr>
@@ -6803,7 +7041,7 @@
           <p:cNvPr id="2" name="">
             <a:extLst xmlns:a="http://schemas.openxmlformats.org/drawingml/2006/main">
               <a:ext uri="{FF2B5EF4-FFF2-40B4-BE49-F238E27FC236}">
-                <a16:creationId xmlns:a16="http://schemas.microsoft.com/office/drawing/2014/main" id="{274FF35C-D531-48ED-A9B1-F148549DFB03}"/>
+                <a16:creationId xmlns:a16="http://schemas.microsoft.com/office/drawing/2014/main" id="{648AB9AD-74AA-4896-BBF5-664BD755A89B}"/>
               </a:ext>
             </a:extLst>
           </p:cNvPr>
@@ -6864,7 +7102,7 @@
           <p:cNvPr id="3" name="">
             <a:extLst xmlns:a="http://schemas.openxmlformats.org/drawingml/2006/main">
               <a:ext uri="{FF2B5EF4-FFF2-40B4-BE49-F238E27FC236}">
-                <a16:creationId xmlns:a16="http://schemas.microsoft.com/office/drawing/2014/main" id="{0BB042AF-B670-446D-95A4-8BA9C447978C}"/>
+                <a16:creationId xmlns:a16="http://schemas.microsoft.com/office/drawing/2014/main" id="{3BA98121-B50F-49F5-A9A8-77A8A57912F3}"/>
               </a:ext>
             </a:extLst>
           </p:cNvPr>
@@ -6925,7 +7163,7 @@
           <p:cNvPr id="4" name="">
             <a:extLst xmlns:a="http://schemas.openxmlformats.org/drawingml/2006/main">
               <a:ext uri="{FF2B5EF4-FFF2-40B4-BE49-F238E27FC236}">
-                <a16:creationId xmlns:a16="http://schemas.microsoft.com/office/drawing/2014/main" id="{D7B0F2CE-BE69-4081-A026-C5457E0B1E5E}"/>
+                <a16:creationId xmlns:a16="http://schemas.microsoft.com/office/drawing/2014/main" id="{602CC17D-C718-4EFE-A327-0E7BCA7438C5}"/>
               </a:ext>
             </a:extLst>
           </p:cNvPr>
@@ -6986,7 +7224,7 @@
           <p:cNvPr id="5" name="">
             <a:extLst xmlns:a="http://schemas.openxmlformats.org/drawingml/2006/main">
               <a:ext uri="{FF2B5EF4-FFF2-40B4-BE49-F238E27FC236}">
-                <a16:creationId xmlns:a16="http://schemas.microsoft.com/office/drawing/2014/main" id="{312D97D2-1932-4C7D-AB7E-47748F2D326F}"/>
+                <a16:creationId xmlns:a16="http://schemas.microsoft.com/office/drawing/2014/main" id="{381CA83D-7C44-40B8-A799-94C8F1955950}"/>
               </a:ext>
             </a:extLst>
           </p:cNvPr>
@@ -7017,7 +7255,7 @@
           <p:cNvPr id="6" name="">
             <a:extLst xmlns:a="http://schemas.openxmlformats.org/drawingml/2006/main">
               <a:ext uri="{FF2B5EF4-FFF2-40B4-BE49-F238E27FC236}">
-                <a16:creationId xmlns:a16="http://schemas.microsoft.com/office/drawing/2014/main" id="{188EBB60-C32E-4F94-B65C-36BA9EC2B405}"/>
+                <a16:creationId xmlns:a16="http://schemas.microsoft.com/office/drawing/2014/main" id="{99B53178-70EE-4BC2-BFE3-36ACC33D0546}"/>
               </a:ext>
             </a:extLst>
           </p:cNvPr>
@@ -7078,7 +7316,7 @@
           <p:cNvPr id="7" name="">
             <a:extLst xmlns:a="http://schemas.openxmlformats.org/drawingml/2006/main">
               <a:ext uri="{FF2B5EF4-FFF2-40B4-BE49-F238E27FC236}">
-                <a16:creationId xmlns:a16="http://schemas.microsoft.com/office/drawing/2014/main" id="{92635ED9-1084-48AA-B21D-479511AB9230}"/>
+                <a16:creationId xmlns:a16="http://schemas.microsoft.com/office/drawing/2014/main" id="{792E26B6-D6BF-4C42-AC85-BA10D7C1E712}"/>
               </a:ext>
             </a:extLst>
           </p:cNvPr>
@@ -7139,7 +7377,7 @@
           <p:cNvPr id="8" name="">
             <a:extLst xmlns:a="http://schemas.openxmlformats.org/drawingml/2006/main">
               <a:ext uri="{FF2B5EF4-FFF2-40B4-BE49-F238E27FC236}">
-                <a16:creationId xmlns:a16="http://schemas.microsoft.com/office/drawing/2014/main" id="{A3DB2EAF-423E-4F96-8D82-F86B34BE6242}"/>
+                <a16:creationId xmlns:a16="http://schemas.microsoft.com/office/drawing/2014/main" id="{E833B021-2FA4-4340-8468-1A6C76C9DDC2}"/>
               </a:ext>
             </a:extLst>
           </p:cNvPr>
@@ -7198,7 +7436,7 @@
     </p:spTree>
     <p:extLst>
       <p:ext uri="{BB962C8B-B14F-4D97-AF65-F5344CB8AC3E}">
-        <p14:creationId xmlns:p14="http://schemas.microsoft.com/office/powerpoint/2010/main" val="944119964"/>
+        <p14:creationId xmlns:p14="http://schemas.microsoft.com/office/powerpoint/2010/main" val="295774442"/>
       </p:ext>
     </p:extLst>
   </p:cSld>

</xml_diff>